<commit_message>
docs(ppt): update presentation slides, review notes, and analysis notebooks
</commit_message>
<xml_diff>
--- a/ppt/Pneumonia_detection.pptx
+++ b/ppt/Pneumonia_detection.pptx
@@ -5,23 +5,24 @@
     <p:sldMasterId id="2147483648" r:id="rId4"/>
   </p:sldMasterIdLst>
   <p:notesMasterIdLst>
-    <p:notesMasterId r:id="rId16"/>
+    <p:notesMasterId r:id="rId17"/>
   </p:notesMasterIdLst>
   <p:handoutMasterIdLst>
-    <p:handoutMasterId r:id="rId17"/>
+    <p:handoutMasterId r:id="rId18"/>
   </p:handoutMasterIdLst>
   <p:sldIdLst>
     <p:sldId id="256" r:id="rId5"/>
-    <p:sldId id="288" r:id="rId6"/>
-    <p:sldId id="257" r:id="rId7"/>
-    <p:sldId id="260" r:id="rId8"/>
-    <p:sldId id="282" r:id="rId9"/>
-    <p:sldId id="284" r:id="rId10"/>
-    <p:sldId id="289" r:id="rId11"/>
-    <p:sldId id="285" r:id="rId12"/>
-    <p:sldId id="265" r:id="rId13"/>
-    <p:sldId id="287" r:id="rId14"/>
-    <p:sldId id="280" r:id="rId15"/>
+    <p:sldId id="290" r:id="rId6"/>
+    <p:sldId id="288" r:id="rId7"/>
+    <p:sldId id="257" r:id="rId8"/>
+    <p:sldId id="260" r:id="rId9"/>
+    <p:sldId id="282" r:id="rId10"/>
+    <p:sldId id="284" r:id="rId11"/>
+    <p:sldId id="289" r:id="rId12"/>
+    <p:sldId id="285" r:id="rId13"/>
+    <p:sldId id="265" r:id="rId14"/>
+    <p:sldId id="287" r:id="rId15"/>
+    <p:sldId id="280" r:id="rId16"/>
   </p:sldIdLst>
   <p:sldSz cx="12192000" cy="6858000"/>
   <p:notesSz cx="6858000" cy="9144000"/>
@@ -225,7 +226,7 @@
           <a:p>
             <a:fld id="{EF1077DB-935E-4A0A-947A-D283B9F9F452}" type="datetimeFigureOut">
               <a:rPr lang="en-US" smtClean="0"/>
-              <a:t>6/29/2020</a:t>
+              <a:t>7/30/2020</a:t>
             </a:fld>
             <a:endParaRPr lang="en-US" dirty="0"/>
           </a:p>
@@ -402,7 +403,7 @@
           <a:p>
             <a:fld id="{19EDBDA2-4480-4D82-8886-1B64A7ECBBAC}" type="datetimeFigureOut">
               <a:rPr lang="en-US" noProof="0" smtClean="0"/>
-              <a:t>6/29/2020</a:t>
+              <a:t>7/30/2020</a:t>
             </a:fld>
             <a:endParaRPr lang="en-US" noProof="0" dirty="0"/>
           </a:p>
@@ -827,7 +828,7 @@
     </p:spTree>
     <p:extLst>
       <p:ext uri="{BB962C8B-B14F-4D97-AF65-F5344CB8AC3E}">
-        <p14:creationId xmlns:p14="http://schemas.microsoft.com/office/powerpoint/2010/main" val="3968791080"/>
+        <p14:creationId xmlns:p14="http://schemas.microsoft.com/office/powerpoint/2010/main" val="2859646611"/>
       </p:ext>
     </p:extLst>
   </p:cSld>
@@ -911,7 +912,7 @@
     </p:spTree>
     <p:extLst>
       <p:ext uri="{BB962C8B-B14F-4D97-AF65-F5344CB8AC3E}">
-        <p14:creationId xmlns:p14="http://schemas.microsoft.com/office/powerpoint/2010/main" val="3856706899"/>
+        <p14:creationId xmlns:p14="http://schemas.microsoft.com/office/powerpoint/2010/main" val="3968791080"/>
       </p:ext>
     </p:extLst>
   </p:cSld>
@@ -995,7 +996,7 @@
     </p:spTree>
     <p:extLst>
       <p:ext uri="{BB962C8B-B14F-4D97-AF65-F5344CB8AC3E}">
-        <p14:creationId xmlns:p14="http://schemas.microsoft.com/office/powerpoint/2010/main" val="1140647699"/>
+        <p14:creationId xmlns:p14="http://schemas.microsoft.com/office/powerpoint/2010/main" val="3856706899"/>
       </p:ext>
     </p:extLst>
   </p:cSld>
@@ -1070,7 +1071,7 @@
           <a:p>
             <a:fld id="{EFDDBACE-0F8F-43FD-98F0-DEE13552DADA}" type="slidenum">
               <a:rPr lang="en-US" noProof="0" smtClean="0"/>
-              <a:t>8</a:t>
+              <a:t>5</a:t>
             </a:fld>
             <a:endParaRPr lang="en-US" noProof="0" dirty="0"/>
           </a:p>
@@ -1079,7 +1080,7 @@
     </p:spTree>
     <p:extLst>
       <p:ext uri="{BB962C8B-B14F-4D97-AF65-F5344CB8AC3E}">
-        <p14:creationId xmlns:p14="http://schemas.microsoft.com/office/powerpoint/2010/main" val="2467938471"/>
+        <p14:creationId xmlns:p14="http://schemas.microsoft.com/office/powerpoint/2010/main" val="1140647699"/>
       </p:ext>
     </p:extLst>
   </p:cSld>
@@ -1163,7 +1164,7 @@
     </p:spTree>
     <p:extLst>
       <p:ext uri="{BB962C8B-B14F-4D97-AF65-F5344CB8AC3E}">
-        <p14:creationId xmlns:p14="http://schemas.microsoft.com/office/powerpoint/2010/main" val="3349418384"/>
+        <p14:creationId xmlns:p14="http://schemas.microsoft.com/office/powerpoint/2010/main" val="2467938471"/>
       </p:ext>
     </p:extLst>
   </p:cSld>
@@ -1247,7 +1248,7 @@
     </p:spTree>
     <p:extLst>
       <p:ext uri="{BB962C8B-B14F-4D97-AF65-F5344CB8AC3E}">
-        <p14:creationId xmlns:p14="http://schemas.microsoft.com/office/powerpoint/2010/main" val="4279615253"/>
+        <p14:creationId xmlns:p14="http://schemas.microsoft.com/office/powerpoint/2010/main" val="3349418384"/>
       </p:ext>
     </p:extLst>
   </p:cSld>
@@ -1312,7 +1313,7 @@
             <a:spLocks noGrp="1"/>
           </p:cNvSpPr>
           <p:nvPr>
-            <p:ph type="sldNum" sz="quarter" idx="10"/>
+            <p:ph type="sldNum" sz="quarter" idx="5"/>
           </p:nvPr>
         </p:nvSpPr>
         <p:spPr/>
@@ -1321,8 +1322,92 @@
           <a:lstStyle/>
           <a:p>
             <a:fld id="{EFDDBACE-0F8F-43FD-98F0-DEE13552DADA}" type="slidenum">
+              <a:rPr lang="en-US" noProof="0" smtClean="0"/>
+              <a:t>11</a:t>
+            </a:fld>
+            <a:endParaRPr lang="en-US" noProof="0" dirty="0"/>
+          </a:p>
+        </p:txBody>
+      </p:sp>
+    </p:spTree>
+    <p:extLst>
+      <p:ext uri="{BB962C8B-B14F-4D97-AF65-F5344CB8AC3E}">
+        <p14:creationId xmlns:p14="http://schemas.microsoft.com/office/powerpoint/2010/main" val="4279615253"/>
+      </p:ext>
+    </p:extLst>
+  </p:cSld>
+  <p:clrMapOvr>
+    <a:masterClrMapping/>
+  </p:clrMapOvr>
+</p:notes>
+</file>
+
+<file path=ppt/notesSlides/notesSlide9.xml><?xml version="1.0" encoding="utf-8"?>
+<p:notes xmlns:a="http://schemas.openxmlformats.org/drawingml/2006/main" xmlns:r="http://schemas.openxmlformats.org/officeDocument/2006/relationships" xmlns:p="http://schemas.openxmlformats.org/presentationml/2006/main">
+  <p:cSld>
+    <p:spTree>
+      <p:nvGrpSpPr>
+        <p:cNvPr id="1" name=""/>
+        <p:cNvGrpSpPr/>
+        <p:nvPr/>
+      </p:nvGrpSpPr>
+      <p:grpSpPr>
+        <a:xfrm>
+          <a:off x="0" y="0"/>
+          <a:ext cx="0" cy="0"/>
+          <a:chOff x="0" y="0"/>
+          <a:chExt cx="0" cy="0"/>
+        </a:xfrm>
+      </p:grpSpPr>
+      <p:sp>
+        <p:nvSpPr>
+          <p:cNvPr id="2" name="Slide Image Placeholder 1"/>
+          <p:cNvSpPr>
+            <a:spLocks noGrp="1" noRot="1" noChangeAspect="1"/>
+          </p:cNvSpPr>
+          <p:nvPr>
+            <p:ph type="sldImg"/>
+          </p:nvPr>
+        </p:nvSpPr>
+        <p:spPr/>
+      </p:sp>
+      <p:sp>
+        <p:nvSpPr>
+          <p:cNvPr id="3" name="Notes Placeholder 2"/>
+          <p:cNvSpPr>
+            <a:spLocks noGrp="1"/>
+          </p:cNvSpPr>
+          <p:nvPr>
+            <p:ph type="body" idx="1"/>
+          </p:nvPr>
+        </p:nvSpPr>
+        <p:spPr/>
+        <p:txBody>
+          <a:bodyPr/>
+          <a:lstStyle/>
+          <a:p>
+            <a:endParaRPr lang="en-US"/>
+          </a:p>
+        </p:txBody>
+      </p:sp>
+      <p:sp>
+        <p:nvSpPr>
+          <p:cNvPr id="4" name="Slide Number Placeholder 3"/>
+          <p:cNvSpPr>
+            <a:spLocks noGrp="1"/>
+          </p:cNvSpPr>
+          <p:nvPr>
+            <p:ph type="sldNum" sz="quarter" idx="10"/>
+          </p:nvPr>
+        </p:nvSpPr>
+        <p:spPr/>
+        <p:txBody>
+          <a:bodyPr/>
+          <a:lstStyle/>
+          <a:p>
+            <a:fld id="{EFDDBACE-0F8F-43FD-98F0-DEE13552DADA}" type="slidenum">
               <a:rPr lang="en-US" smtClean="0"/>
-              <a:t>11</a:t>
+              <a:t>12</a:t>
             </a:fld>
             <a:endParaRPr lang="en-US"/>
           </a:p>
@@ -19623,8 +19708,8 @@
         </p:blipFill>
         <p:spPr>
           <a:xfrm>
-            <a:off x="460082" y="96318"/>
-            <a:ext cx="11384915" cy="6584950"/>
+            <a:off x="464754" y="135743"/>
+            <a:ext cx="11014483" cy="6584950"/>
           </a:xfrm>
         </p:spPr>
       </p:pic>
@@ -19645,8 +19730,8 @@
         </p:nvSpPr>
         <p:spPr bwMode="invGray">
           <a:xfrm rot="5400000">
-            <a:off x="5430641" y="266912"/>
-            <a:ext cx="6584950" cy="6243762"/>
+            <a:off x="5548442" y="438205"/>
+            <a:ext cx="6584950" cy="6064435"/>
           </a:xfrm>
           <a:prstGeom prst="rect">
             <a:avLst/>
@@ -19703,7 +19788,7 @@
         </p:nvSpPr>
         <p:spPr bwMode="black">
           <a:xfrm>
-            <a:off x="4644632" y="464869"/>
+            <a:off x="5808699" y="400073"/>
             <a:ext cx="5085650" cy="691666"/>
           </a:xfrm>
         </p:spPr>
@@ -19712,10 +19797,9 @@
           <a:lstStyle/>
           <a:p>
             <a:r>
-              <a:rPr lang="en-US" dirty="0"/>
-              <a:t>Future Work</a:t>
-            </a:r>
-            <a:endParaRPr lang="en-US" b="1" dirty="0"/>
+              <a:rPr lang="en-US" b="1" dirty="0"/>
+              <a:t>Recommendations:</a:t>
+            </a:r>
           </a:p>
         </p:txBody>
       </p:sp>
@@ -19737,63 +19821,74 @@
         </p:nvSpPr>
         <p:spPr bwMode="black">
           <a:xfrm>
-            <a:off x="5702169" y="1398670"/>
-            <a:ext cx="6041893" cy="4762979"/>
+            <a:off x="6194484" y="1218512"/>
+            <a:ext cx="5383228" cy="4419412"/>
           </a:xfrm>
         </p:spPr>
         <p:txBody>
           <a:bodyPr/>
           <a:lstStyle/>
           <a:p>
-            <a:endParaRPr lang="en-US" b="1" dirty="0"/>
-          </a:p>
-          <a:p>
-            <a:pPr algn="ctr"/>
+            <a:pPr algn="l"/>
             <a:r>
               <a:rPr lang="en-US" b="1" dirty="0">
                 <a:solidFill>
-                  <a:schemeClr val="accent2">
-                    <a:lumMod val="40000"/>
-                    <a:lumOff val="60000"/>
-                  </a:schemeClr>
+                  <a:srgbClr val="FFC000"/>
                 </a:solidFill>
               </a:rPr>
-              <a:t>We need more data to run our validation set on so that we can be sure of the way the model is predicting.</a:t>
-            </a:r>
-          </a:p>
-          <a:p>
-            <a:pPr algn="ctr"/>
-            <a:endParaRPr lang="en-US" b="1" dirty="0">
+              <a:t>Incorporate our model to see how it works in hospitals so that it can assist health professionals diagnose patients with Pneumonia. </a:t>
+            </a:r>
+          </a:p>
+          <a:p>
+            <a:pPr algn="l"/>
+            <a:r>
+              <a:rPr lang="en-US" b="1" dirty="0">
+                <a:solidFill>
+                  <a:srgbClr val="FFC000"/>
+                </a:solidFill>
+              </a:rPr>
+              <a:t>Of course these reports must be validated. This is not the ultimate test. This needs to be certified by health professionals.</a:t>
+            </a:r>
+          </a:p>
+          <a:p>
+            <a:pPr algn="l"/>
+            <a:br>
+              <a:rPr lang="en-US" b="1" dirty="0">
+                <a:solidFill>
+                  <a:srgbClr val="FFC000"/>
+                </a:solidFill>
+              </a:rPr>
+            </a:br>
+            <a:r>
+              <a:rPr lang="en-US" b="1" dirty="0">
+                <a:solidFill>
+                  <a:srgbClr val="FFC000"/>
+                </a:solidFill>
+              </a:rPr>
+              <a:t>This model should be run under the supervision of a radiologist to enhance accuracy/recall to improve treatment outcomes which will increase hospitals ratings and </a:t>
+            </a:r>
+            <a:r>
+              <a:rPr lang="en-US" b="1" dirty="0" err="1">
+                <a:solidFill>
+                  <a:srgbClr val="FFC000"/>
+                </a:solidFill>
+              </a:rPr>
+              <a:t>fundings</a:t>
+            </a:r>
+            <a:r>
+              <a:rPr lang="en-US" b="1" dirty="0">
+                <a:solidFill>
+                  <a:srgbClr val="FFC000"/>
+                </a:solidFill>
+              </a:rPr>
+              <a:t>.</a:t>
+            </a:r>
+            <a:endParaRPr lang="en-US" dirty="0">
               <a:solidFill>
-                <a:schemeClr val="accent2">
-                  <a:lumMod val="40000"/>
-                  <a:lumOff val="60000"/>
-                </a:schemeClr>
+                <a:srgbClr val="FFC000"/>
               </a:solidFill>
             </a:endParaRPr>
           </a:p>
-          <a:p>
-            <a:pPr algn="ctr"/>
-            <a:r>
-              <a:rPr lang="en-US" b="1" dirty="0">
-                <a:solidFill>
-                  <a:schemeClr val="accent2">
-                    <a:lumMod val="40000"/>
-                    <a:lumOff val="60000"/>
-                  </a:schemeClr>
-                </a:solidFill>
-              </a:rPr>
-              <a:t>Also, work towards getting our Transfer Learning model to work better.</a:t>
-            </a:r>
-            <a:endParaRPr lang="en-US" dirty="0">
-              <a:solidFill>
-                <a:schemeClr val="accent2">
-                  <a:lumMod val="40000"/>
-                  <a:lumOff val="60000"/>
-                </a:schemeClr>
-              </a:solidFill>
-            </a:endParaRPr>
-          </a:p>
         </p:txBody>
       </p:sp>
       <p:sp>
@@ -19814,7 +19909,7 @@
         </p:nvSpPr>
         <p:spPr>
           <a:xfrm>
-            <a:off x="11250520" y="6416937"/>
+            <a:off x="11245848" y="6456363"/>
             <a:ext cx="962795" cy="264330"/>
           </a:xfrm>
           <a:ln>
@@ -19853,7 +19948,7 @@
     </p:spTree>
     <p:extLst>
       <p:ext uri="{BB962C8B-B14F-4D97-AF65-F5344CB8AC3E}">
-        <p14:creationId xmlns:p14="http://schemas.microsoft.com/office/powerpoint/2010/main" val="2205769443"/>
+        <p14:creationId xmlns:p14="http://schemas.microsoft.com/office/powerpoint/2010/main" val="833142177"/>
       </p:ext>
     </p:extLst>
   </p:cSld>
@@ -19882,10 +19977,10 @@
       </p:grpSpPr>
       <p:pic>
         <p:nvPicPr>
-          <p:cNvPr id="21" name="Picture Placeholder 16" descr="Image containing medical tweezers of various sizes, some pills, and a hand holding a pen writing on a piece of paper attached to a clipboard">
-            <a:extLst>
-              <a:ext uri="{FF2B5EF4-FFF2-40B4-BE49-F238E27FC236}">
-                <a16:creationId xmlns:a16="http://schemas.microsoft.com/office/drawing/2014/main" id="{D29AD2ED-F2E1-42BA-A4F8-29194C963478}"/>
+          <p:cNvPr id="8" name="Picture Placeholder 7" descr="Image containing medical tweezers of various sizes, some pills, and a hand holding a pen writing on a piece of paper attached to a clipboard">
+            <a:extLst>
+              <a:ext uri="{FF2B5EF4-FFF2-40B4-BE49-F238E27FC236}">
+                <a16:creationId xmlns:a16="http://schemas.microsoft.com/office/drawing/2014/main" id="{58E8F1D1-2E7D-42A1-89B1-02F0157F588D}"/>
               </a:ext>
             </a:extLst>
           </p:cNvPr>
@@ -19904,24 +19999,24 @@
               </a:ext>
             </a:extLst>
           </a:blip>
-          <a:srcRect l="62" r="62"/>
+          <a:srcRect/>
           <a:stretch>
             <a:fillRect/>
           </a:stretch>
         </p:blipFill>
         <p:spPr>
           <a:xfrm>
-            <a:off x="253218" y="136525"/>
-            <a:ext cx="11816862" cy="6584950"/>
+            <a:off x="460082" y="96318"/>
+            <a:ext cx="11384915" cy="6584950"/>
           </a:xfrm>
         </p:spPr>
       </p:pic>
       <p:sp>
         <p:nvSpPr>
-          <p:cNvPr id="11" name="Rectangle 10">
-            <a:extLst>
-              <a:ext uri="{FF2B5EF4-FFF2-40B4-BE49-F238E27FC236}">
-                <a16:creationId xmlns:a16="http://schemas.microsoft.com/office/drawing/2014/main" id="{5396BE43-2D46-4002-A946-60FC5900EC15}"/>
+          <p:cNvPr id="12" name="Rectangle 11">
+            <a:extLst>
+              <a:ext uri="{FF2B5EF4-FFF2-40B4-BE49-F238E27FC236}">
+                <a16:creationId xmlns:a16="http://schemas.microsoft.com/office/drawing/2014/main" id="{1D3F6556-8AF2-4DC2-86FE-E38011E946E6}"/>
               </a:ext>
               <a:ext uri="{C183D7F6-B498-43B3-948B-1728B52AA6E4}">
                 <adec:decorative xmlns:adec="http://schemas.microsoft.com/office/drawing/2017/decorative" val="1"/>
@@ -19933,8 +20028,8 @@
         </p:nvSpPr>
         <p:spPr bwMode="invGray">
           <a:xfrm rot="5400000">
-            <a:off x="5939414" y="590809"/>
-            <a:ext cx="6584950" cy="5676382"/>
+            <a:off x="5430641" y="266912"/>
+            <a:ext cx="6584950" cy="6243762"/>
           </a:xfrm>
           <a:prstGeom prst="rect">
             <a:avLst/>
@@ -19978,7 +20073,7 @@
           <p:cNvPr id="3" name="Title 2">
             <a:extLst>
               <a:ext uri="{FF2B5EF4-FFF2-40B4-BE49-F238E27FC236}">
-                <a16:creationId xmlns:a16="http://schemas.microsoft.com/office/drawing/2014/main" id="{D2DDABB1-5E6B-4365-AD9E-DDCE7E972742}"/>
+                <a16:creationId xmlns:a16="http://schemas.microsoft.com/office/drawing/2014/main" id="{697DC055-29AA-4AE9-8621-A0765113CDFB}"/>
               </a:ext>
             </a:extLst>
           </p:cNvPr>
@@ -19989,10 +20084,10 @@
             <p:ph type="ctrTitle"/>
           </p:nvPr>
         </p:nvSpPr>
-        <p:spPr>
-          <a:xfrm>
-            <a:off x="5798302" y="900435"/>
-            <a:ext cx="5276725" cy="1870007"/>
+        <p:spPr bwMode="black">
+          <a:xfrm>
+            <a:off x="4644632" y="464869"/>
+            <a:ext cx="5085650" cy="691666"/>
           </a:xfrm>
         </p:spPr>
         <p:txBody>
@@ -20001,8 +20096,9 @@
           <a:p>
             <a:r>
               <a:rPr lang="en-US" dirty="0"/>
-              <a:t>Thank You</a:t>
-            </a:r>
+              <a:t>Future Work</a:t>
+            </a:r>
+            <a:endParaRPr lang="en-US" b="1" dirty="0"/>
           </a:p>
         </p:txBody>
       </p:sp>
@@ -20011,7 +20107,7 @@
           <p:cNvPr id="4" name="Subtitle 3">
             <a:extLst>
               <a:ext uri="{FF2B5EF4-FFF2-40B4-BE49-F238E27FC236}">
-                <a16:creationId xmlns:a16="http://schemas.microsoft.com/office/drawing/2014/main" id="{37530160-A714-49C8-85A0-932553905B40}"/>
+                <a16:creationId xmlns:a16="http://schemas.microsoft.com/office/drawing/2014/main" id="{4CAFB058-F34E-4FAC-AA90-D1CB170C9984}"/>
               </a:ext>
             </a:extLst>
           </p:cNvPr>
@@ -20022,251 +20118,125 @@
             <p:ph type="subTitle" idx="1"/>
           </p:nvPr>
         </p:nvSpPr>
-        <p:spPr>
-          <a:xfrm>
-            <a:off x="6161649" y="5387809"/>
-            <a:ext cx="4681330" cy="956603"/>
+        <p:spPr bwMode="black">
+          <a:xfrm>
+            <a:off x="5702169" y="1398670"/>
+            <a:ext cx="6041893" cy="4762979"/>
           </a:xfrm>
         </p:spPr>
         <p:txBody>
           <a:bodyPr/>
           <a:lstStyle/>
           <a:p>
-            <a:r>
-              <a:rPr lang="en-US" sz="2400" b="1" dirty="0"/>
-              <a:t>Any Questions </a:t>
-            </a:r>
-            <a:r>
-              <a:rPr lang="en-US" sz="2400" b="1" dirty="0">
-                <a:sym typeface="Wingdings" panose="05000000000000000000" pitchFamily="2" charset="2"/>
+            <a:endParaRPr lang="en-US" b="1" dirty="0"/>
+          </a:p>
+          <a:p>
+            <a:pPr algn="ctr"/>
+            <a:r>
+              <a:rPr lang="en-US" b="1" dirty="0">
+                <a:solidFill>
+                  <a:schemeClr val="accent2">
+                    <a:lumMod val="40000"/>
+                    <a:lumOff val="60000"/>
+                  </a:schemeClr>
+                </a:solidFill>
               </a:rPr>
-              <a:t></a:t>
-            </a:r>
-            <a:r>
-              <a:rPr lang="en-US" sz="2400" b="1" dirty="0"/>
-              <a:t> ???</a:t>
-            </a:r>
-          </a:p>
-        </p:txBody>
-      </p:sp>
-      <p:sp>
-        <p:nvSpPr>
-          <p:cNvPr id="6" name="Subtitle 3">
-            <a:extLst>
-              <a:ext uri="{FF2B5EF4-FFF2-40B4-BE49-F238E27FC236}">
-                <a16:creationId xmlns:a16="http://schemas.microsoft.com/office/drawing/2014/main" id="{81D4D4A1-9BF0-4F1D-A8DD-F313309D5A28}"/>
-              </a:ext>
-            </a:extLst>
-          </p:cNvPr>
-          <p:cNvSpPr txBox="1">
-            <a:spLocks/>
-          </p:cNvSpPr>
-          <p:nvPr/>
-        </p:nvSpPr>
-        <p:spPr>
-          <a:xfrm>
-            <a:off x="7705897" y="3225993"/>
-            <a:ext cx="3051984" cy="1774969"/>
-          </a:xfrm>
-          <a:prstGeom prst="rect">
-            <a:avLst/>
-          </a:prstGeom>
-        </p:spPr>
-        <p:txBody>
-          <a:bodyPr vert="horz" lIns="0" tIns="0" rIns="0" bIns="0" rtlCol="0">
-            <a:noAutofit/>
-          </a:bodyPr>
-          <a:lstStyle>
-            <a:defPPr>
-              <a:defRPr lang="en-US"/>
-            </a:defPPr>
-            <a:lvl1pPr marL="0" algn="l" defTabSz="914400" rtl="0" eaLnBrk="1" latinLnBrk="0" hangingPunct="1">
-              <a:defRPr sz="1800" kern="1200">
-                <a:solidFill>
-                  <a:schemeClr val="tx1"/>
-                </a:solidFill>
-                <a:latin typeface="+mn-lt"/>
-                <a:ea typeface="+mn-ea"/>
-                <a:cs typeface="+mn-cs"/>
-              </a:defRPr>
-            </a:lvl1pPr>
-            <a:lvl2pPr marL="457200" algn="l" defTabSz="914400" rtl="0" eaLnBrk="1" latinLnBrk="0" hangingPunct="1">
-              <a:defRPr sz="1800" kern="1200">
-                <a:solidFill>
-                  <a:schemeClr val="tx1"/>
-                </a:solidFill>
-                <a:latin typeface="+mn-lt"/>
-                <a:ea typeface="+mn-ea"/>
-                <a:cs typeface="+mn-cs"/>
-              </a:defRPr>
-            </a:lvl2pPr>
-            <a:lvl3pPr marL="914400" algn="l" defTabSz="914400" rtl="0" eaLnBrk="1" latinLnBrk="0" hangingPunct="1">
-              <a:defRPr sz="1800" kern="1200">
-                <a:solidFill>
-                  <a:schemeClr val="tx1"/>
-                </a:solidFill>
-                <a:latin typeface="+mn-lt"/>
-                <a:ea typeface="+mn-ea"/>
-                <a:cs typeface="+mn-cs"/>
-              </a:defRPr>
-            </a:lvl3pPr>
-            <a:lvl4pPr marL="1371600" algn="l" defTabSz="914400" rtl="0" eaLnBrk="1" latinLnBrk="0" hangingPunct="1">
-              <a:defRPr sz="1800" kern="1200">
-                <a:solidFill>
-                  <a:schemeClr val="tx1"/>
-                </a:solidFill>
-                <a:latin typeface="+mn-lt"/>
-                <a:ea typeface="+mn-ea"/>
-                <a:cs typeface="+mn-cs"/>
-              </a:defRPr>
-            </a:lvl4pPr>
-            <a:lvl5pPr marL="1828800" algn="l" defTabSz="914400" rtl="0" eaLnBrk="1" latinLnBrk="0" hangingPunct="1">
-              <a:defRPr sz="1800" kern="1200">
-                <a:solidFill>
-                  <a:schemeClr val="tx1"/>
-                </a:solidFill>
-                <a:latin typeface="+mn-lt"/>
-                <a:ea typeface="+mn-ea"/>
-                <a:cs typeface="+mn-cs"/>
-              </a:defRPr>
-            </a:lvl5pPr>
-            <a:lvl6pPr marL="2286000" algn="l" defTabSz="914400" rtl="0" eaLnBrk="1" latinLnBrk="0" hangingPunct="1">
-              <a:defRPr sz="1800" kern="1200">
-                <a:solidFill>
-                  <a:schemeClr val="tx1"/>
-                </a:solidFill>
-                <a:latin typeface="+mn-lt"/>
-                <a:ea typeface="+mn-ea"/>
-                <a:cs typeface="+mn-cs"/>
-              </a:defRPr>
-            </a:lvl6pPr>
-            <a:lvl7pPr marL="2743200" algn="l" defTabSz="914400" rtl="0" eaLnBrk="1" latinLnBrk="0" hangingPunct="1">
-              <a:defRPr sz="1800" kern="1200">
-                <a:solidFill>
-                  <a:schemeClr val="tx1"/>
-                </a:solidFill>
-                <a:latin typeface="+mn-lt"/>
-                <a:ea typeface="+mn-ea"/>
-                <a:cs typeface="+mn-cs"/>
-              </a:defRPr>
-            </a:lvl7pPr>
-            <a:lvl8pPr marL="3200400" algn="l" defTabSz="914400" rtl="0" eaLnBrk="1" latinLnBrk="0" hangingPunct="1">
-              <a:defRPr sz="1800" kern="1200">
-                <a:solidFill>
-                  <a:schemeClr val="tx1"/>
-                </a:solidFill>
-                <a:latin typeface="+mn-lt"/>
-                <a:ea typeface="+mn-ea"/>
-                <a:cs typeface="+mn-cs"/>
-              </a:defRPr>
-            </a:lvl8pPr>
-            <a:lvl9pPr marL="3657600" algn="l" defTabSz="914400" rtl="0" eaLnBrk="1" latinLnBrk="0" hangingPunct="1">
-              <a:defRPr sz="1800" kern="1200">
-                <a:solidFill>
-                  <a:schemeClr val="tx1"/>
-                </a:solidFill>
-                <a:latin typeface="+mn-lt"/>
-                <a:ea typeface="+mn-ea"/>
-                <a:cs typeface="+mn-cs"/>
-              </a:defRPr>
-            </a:lvl9pPr>
-          </a:lstStyle>
-          <a:p>
-            <a:pPr marL="342900" indent="-342900" algn="l">
-              <a:buFont typeface="Arial" panose="020B0604020202020204" pitchFamily="34" charset="0"/>
-              <a:buChar char="•"/>
-            </a:pPr>
-            <a:r>
-              <a:rPr lang="en-US" sz="2400" b="1" dirty="0">
-                <a:solidFill>
-                  <a:srgbClr val="92D050"/>
-                </a:solidFill>
-              </a:rPr>
-              <a:t>Amber </a:t>
-            </a:r>
-            <a:r>
-              <a:rPr lang="en-US" sz="2400" b="1" dirty="0" err="1">
-                <a:solidFill>
-                  <a:srgbClr val="92D050"/>
-                </a:solidFill>
-              </a:rPr>
-              <a:t>Yandow</a:t>
-            </a:r>
-            <a:endParaRPr lang="en-US" sz="2400" b="1" dirty="0">
+              <a:t>We need more data to run our validation set on so that we can be sure of the way the model is predicting.</a:t>
+            </a:r>
+          </a:p>
+          <a:p>
+            <a:pPr algn="ctr"/>
+            <a:endParaRPr lang="en-US" b="1" dirty="0">
               <a:solidFill>
-                <a:srgbClr val="92D050"/>
+                <a:schemeClr val="accent2">
+                  <a:lumMod val="40000"/>
+                  <a:lumOff val="60000"/>
+                </a:schemeClr>
               </a:solidFill>
             </a:endParaRPr>
           </a:p>
           <a:p>
-            <a:pPr marL="342900" indent="-342900" algn="l">
-              <a:buFont typeface="Arial" panose="020B0604020202020204" pitchFamily="34" charset="0"/>
-              <a:buChar char="•"/>
-            </a:pPr>
-            <a:r>
-              <a:rPr lang="en-US" sz="2400" b="1" dirty="0">
-                <a:solidFill>
-                  <a:srgbClr val="92D050"/>
+            <a:pPr algn="ctr"/>
+            <a:r>
+              <a:rPr lang="en-US" b="1" dirty="0">
+                <a:solidFill>
+                  <a:schemeClr val="accent2">
+                    <a:lumMod val="40000"/>
+                    <a:lumOff val="60000"/>
+                  </a:schemeClr>
                 </a:solidFill>
               </a:rPr>
-              <a:t>Ben Jacobson</a:t>
-            </a:r>
-          </a:p>
-          <a:p>
-            <a:pPr marL="342900" indent="-342900" algn="l">
-              <a:buFont typeface="Arial" panose="020B0604020202020204" pitchFamily="34" charset="0"/>
-              <a:buChar char="•"/>
-            </a:pPr>
-            <a:r>
-              <a:rPr lang="en-US" sz="2400" b="1" dirty="0" err="1">
-                <a:solidFill>
-                  <a:srgbClr val="92D050"/>
-                </a:solidFill>
-              </a:rPr>
-              <a:t>Luay</a:t>
-            </a:r>
-            <a:r>
-              <a:rPr lang="en-US" sz="2400" b="1" dirty="0">
-                <a:solidFill>
-                  <a:srgbClr val="92D050"/>
-                </a:solidFill>
-              </a:rPr>
-              <a:t> </a:t>
-            </a:r>
-            <a:r>
-              <a:rPr lang="en-US" sz="2400" b="1" dirty="0" err="1">
-                <a:solidFill>
-                  <a:srgbClr val="92D050"/>
-                </a:solidFill>
-              </a:rPr>
-              <a:t>Matalka</a:t>
-            </a:r>
-            <a:endParaRPr lang="en-US" sz="2400" b="1" dirty="0">
+              <a:t>Also, work towards getting our Transfer Learning model to work better.</a:t>
+            </a:r>
+            <a:endParaRPr lang="en-US" dirty="0">
               <a:solidFill>
-                <a:srgbClr val="92D050"/>
+                <a:schemeClr val="accent2">
+                  <a:lumMod val="40000"/>
+                  <a:lumOff val="60000"/>
+                </a:schemeClr>
               </a:solidFill>
             </a:endParaRPr>
           </a:p>
-          <a:p>
-            <a:pPr marL="342900" indent="-342900" algn="l">
-              <a:buFont typeface="Arial" panose="020B0604020202020204" pitchFamily="34" charset="0"/>
-              <a:buChar char="•"/>
-            </a:pPr>
-            <a:r>
-              <a:rPr lang="en-US" sz="2400" b="1" dirty="0">
-                <a:solidFill>
-                  <a:srgbClr val="92D050"/>
+        </p:txBody>
+      </p:sp>
+      <p:sp>
+        <p:nvSpPr>
+          <p:cNvPr id="5" name="Slide Number Placeholder 4">
+            <a:extLst>
+              <a:ext uri="{FF2B5EF4-FFF2-40B4-BE49-F238E27FC236}">
+                <a16:creationId xmlns:a16="http://schemas.microsoft.com/office/drawing/2014/main" id="{631703FA-65E2-4E60-B9CE-387169A2F4AE}"/>
+              </a:ext>
+            </a:extLst>
+          </p:cNvPr>
+          <p:cNvSpPr>
+            <a:spLocks noGrp="1"/>
+          </p:cNvSpPr>
+          <p:nvPr>
+            <p:ph type="sldNum" sz="quarter" idx="12"/>
+          </p:nvPr>
+        </p:nvSpPr>
+        <p:spPr>
+          <a:xfrm>
+            <a:off x="11250520" y="6416937"/>
+            <a:ext cx="962795" cy="264330"/>
+          </a:xfrm>
+          <a:ln>
+            <a:noFill/>
+          </a:ln>
+        </p:spPr>
+        <p:txBody>
+          <a:bodyPr/>
+          <a:lstStyle/>
+          <a:p>
+            <a:r>
+              <a:rPr lang="en-US" dirty="0">
+                <a:solidFill>
+                  <a:schemeClr val="bg1"/>
                 </a:solidFill>
               </a:rPr>
-              <a:t>Jesse Neumann</a:t>
-            </a:r>
+              <a:t>page </a:t>
+            </a:r>
+            <a:fld id="{19B51A1E-902D-48AF-9020-955120F399B6}" type="slidenum">
+              <a:rPr lang="en-US" b="1" i="1" smtClean="0">
+                <a:solidFill>
+                  <a:schemeClr val="bg1"/>
+                </a:solidFill>
+              </a:rPr>
+              <a:pPr/>
+              <a:t>11</a:t>
+            </a:fld>
+            <a:endParaRPr lang="en-US" b="1" i="1" dirty="0">
+              <a:solidFill>
+                <a:schemeClr val="bg1"/>
+              </a:solidFill>
+            </a:endParaRPr>
           </a:p>
         </p:txBody>
       </p:sp>
     </p:spTree>
     <p:extLst>
       <p:ext uri="{BB962C8B-B14F-4D97-AF65-F5344CB8AC3E}">
-        <p14:creationId xmlns:p14="http://schemas.microsoft.com/office/powerpoint/2010/main" val="3113318487"/>
+        <p14:creationId xmlns:p14="http://schemas.microsoft.com/office/powerpoint/2010/main" val="2205769443"/>
       </p:ext>
     </p:extLst>
   </p:cSld>
@@ -20276,7 +20246,7 @@
 </p:sld>
 </file>
 
-<file path=ppt/slides/slide2.xml><?xml version="1.0" encoding="utf-8"?>
+<file path=ppt/slides/slide12.xml><?xml version="1.0" encoding="utf-8"?>
 <p:sld xmlns:a="http://schemas.openxmlformats.org/drawingml/2006/main" xmlns:r="http://schemas.openxmlformats.org/officeDocument/2006/relationships" xmlns:p="http://schemas.openxmlformats.org/presentationml/2006/main" showMasterSp="0">
   <p:cSld>
     <p:spTree>
@@ -20293,12 +20263,48 @@
           <a:chExt cx="0" cy="0"/>
         </a:xfrm>
       </p:grpSpPr>
-      <p:sp>
-        <p:nvSpPr>
-          <p:cNvPr id="9" name="Rectangle 8">
-            <a:extLst>
-              <a:ext uri="{FF2B5EF4-FFF2-40B4-BE49-F238E27FC236}">
-                <a16:creationId xmlns:a16="http://schemas.microsoft.com/office/drawing/2014/main" id="{670550D9-B72F-46D0-B3A1-179DADF002AC}"/>
+      <p:pic>
+        <p:nvPicPr>
+          <p:cNvPr id="21" name="Picture Placeholder 16" descr="Image containing medical tweezers of various sizes, some pills, and a hand holding a pen writing on a piece of paper attached to a clipboard">
+            <a:extLst>
+              <a:ext uri="{FF2B5EF4-FFF2-40B4-BE49-F238E27FC236}">
+                <a16:creationId xmlns:a16="http://schemas.microsoft.com/office/drawing/2014/main" id="{D29AD2ED-F2E1-42BA-A4F8-29194C963478}"/>
+              </a:ext>
+            </a:extLst>
+          </p:cNvPr>
+          <p:cNvPicPr>
+            <a:picLocks noGrp="1" noChangeAspect="1"/>
+          </p:cNvPicPr>
+          <p:nvPr>
+            <p:ph type="pic" sz="quarter" idx="10"/>
+          </p:nvPr>
+        </p:nvPicPr>
+        <p:blipFill>
+          <a:blip r:embed="rId3" cstate="screen">
+            <a:extLst>
+              <a:ext uri="{28A0092B-C50C-407E-A947-70E740481C1C}">
+                <a14:useLocalDpi xmlns:a14="http://schemas.microsoft.com/office/drawing/2010/main"/>
+              </a:ext>
+            </a:extLst>
+          </a:blip>
+          <a:srcRect l="62" r="62"/>
+          <a:stretch>
+            <a:fillRect/>
+          </a:stretch>
+        </p:blipFill>
+        <p:spPr>
+          <a:xfrm>
+            <a:off x="253218" y="136525"/>
+            <a:ext cx="11816862" cy="6584950"/>
+          </a:xfrm>
+        </p:spPr>
+      </p:pic>
+      <p:sp>
+        <p:nvSpPr>
+          <p:cNvPr id="11" name="Rectangle 10">
+            <a:extLst>
+              <a:ext uri="{FF2B5EF4-FFF2-40B4-BE49-F238E27FC236}">
+                <a16:creationId xmlns:a16="http://schemas.microsoft.com/office/drawing/2014/main" id="{5396BE43-2D46-4002-A946-60FC5900EC15}"/>
               </a:ext>
               <a:ext uri="{C183D7F6-B498-43B3-948B-1728B52AA6E4}">
                 <adec:decorative xmlns:adec="http://schemas.microsoft.com/office/drawing/2017/decorative" val="1"/>
@@ -20310,8 +20316,8 @@
         </p:nvSpPr>
         <p:spPr bwMode="invGray">
           <a:xfrm rot="5400000">
-            <a:off x="2885104" y="-2512258"/>
-            <a:ext cx="6421793" cy="11882516"/>
+            <a:off x="5939414" y="590809"/>
+            <a:ext cx="6584950" cy="5676382"/>
           </a:xfrm>
           <a:prstGeom prst="rect">
             <a:avLst/>
@@ -20355,7 +20361,7 @@
           <p:cNvPr id="3" name="Title 2">
             <a:extLst>
               <a:ext uri="{FF2B5EF4-FFF2-40B4-BE49-F238E27FC236}">
-                <a16:creationId xmlns:a16="http://schemas.microsoft.com/office/drawing/2014/main" id="{7A663105-4B92-4F24-9DF6-58BB116E29FA}"/>
+                <a16:creationId xmlns:a16="http://schemas.microsoft.com/office/drawing/2014/main" id="{D2DDABB1-5E6B-4365-AD9E-DDCE7E972742}"/>
               </a:ext>
             </a:extLst>
           </p:cNvPr>
@@ -20366,10 +20372,10 @@
             <p:ph type="ctrTitle"/>
           </p:nvPr>
         </p:nvSpPr>
-        <p:spPr bwMode="black">
-          <a:xfrm>
-            <a:off x="3328800" y="492033"/>
-            <a:ext cx="5085650" cy="720000"/>
+        <p:spPr>
+          <a:xfrm>
+            <a:off x="5798302" y="900435"/>
+            <a:ext cx="5276725" cy="1870007"/>
           </a:xfrm>
         </p:spPr>
         <p:txBody>
@@ -20377,8 +20383,8 @@
           <a:lstStyle/>
           <a:p>
             <a:r>
-              <a:rPr lang="en-US" b="1" dirty="0"/>
-              <a:t>About Pneumonia</a:t>
+              <a:rPr lang="en-US" dirty="0"/>
+              <a:t>Thank You</a:t>
             </a:r>
           </a:p>
         </p:txBody>
@@ -20388,7 +20394,7 @@
           <p:cNvPr id="4" name="Subtitle 3">
             <a:extLst>
               <a:ext uri="{FF2B5EF4-FFF2-40B4-BE49-F238E27FC236}">
-                <a16:creationId xmlns:a16="http://schemas.microsoft.com/office/drawing/2014/main" id="{8E41F722-BA6E-4DCA-864E-876ECDFB5336}"/>
+                <a16:creationId xmlns:a16="http://schemas.microsoft.com/office/drawing/2014/main" id="{37530160-A714-49C8-85A0-932553905B40}"/>
               </a:ext>
             </a:extLst>
           </p:cNvPr>
@@ -20399,39 +20405,181 @@
             <p:ph type="subTitle" idx="1"/>
           </p:nvPr>
         </p:nvSpPr>
-        <p:spPr bwMode="black">
-          <a:xfrm>
-            <a:off x="450165" y="1212033"/>
-            <a:ext cx="7166628" cy="5153934"/>
+        <p:spPr>
+          <a:xfrm>
+            <a:off x="6161649" y="5387809"/>
+            <a:ext cx="4681330" cy="956603"/>
           </a:xfrm>
         </p:spPr>
         <p:txBody>
           <a:bodyPr/>
           <a:lstStyle/>
           <a:p>
-            <a:pPr algn="l"/>
-            <a:r>
-              <a:rPr lang="en-US" sz="2000" b="1" dirty="0">
-                <a:solidFill>
-                  <a:srgbClr val="FFC000"/>
-                </a:solidFill>
+            <a:r>
+              <a:rPr lang="en-US" sz="2400" b="1" dirty="0"/>
+              <a:t>Any Questions </a:t>
+            </a:r>
+            <a:r>
+              <a:rPr lang="en-US" sz="2400" b="1" dirty="0">
+                <a:sym typeface="Wingdings" panose="05000000000000000000" pitchFamily="2" charset="2"/>
               </a:rPr>
-              <a:t>Key Facts:</a:t>
-            </a:r>
-          </a:p>
+              <a:t></a:t>
+            </a:r>
+            <a:r>
+              <a:rPr lang="en-US" sz="2400" b="1" dirty="0"/>
+              <a:t> ???</a:t>
+            </a:r>
+          </a:p>
+        </p:txBody>
+      </p:sp>
+      <p:sp>
+        <p:nvSpPr>
+          <p:cNvPr id="6" name="Subtitle 3">
+            <a:extLst>
+              <a:ext uri="{FF2B5EF4-FFF2-40B4-BE49-F238E27FC236}">
+                <a16:creationId xmlns:a16="http://schemas.microsoft.com/office/drawing/2014/main" id="{81D4D4A1-9BF0-4F1D-A8DD-F313309D5A28}"/>
+              </a:ext>
+            </a:extLst>
+          </p:cNvPr>
+          <p:cNvSpPr txBox="1">
+            <a:spLocks/>
+          </p:cNvSpPr>
+          <p:nvPr/>
+        </p:nvSpPr>
+        <p:spPr>
+          <a:xfrm>
+            <a:off x="7705897" y="3225993"/>
+            <a:ext cx="3051984" cy="1774969"/>
+          </a:xfrm>
+          <a:prstGeom prst="rect">
+            <a:avLst/>
+          </a:prstGeom>
+        </p:spPr>
+        <p:txBody>
+          <a:bodyPr vert="horz" lIns="0" tIns="0" rIns="0" bIns="0" rtlCol="0">
+            <a:noAutofit/>
+          </a:bodyPr>
+          <a:lstStyle>
+            <a:defPPr>
+              <a:defRPr lang="en-US"/>
+            </a:defPPr>
+            <a:lvl1pPr marL="0" algn="l" defTabSz="914400" rtl="0" eaLnBrk="1" latinLnBrk="0" hangingPunct="1">
+              <a:defRPr sz="1800" kern="1200">
+                <a:solidFill>
+                  <a:schemeClr val="tx1"/>
+                </a:solidFill>
+                <a:latin typeface="+mn-lt"/>
+                <a:ea typeface="+mn-ea"/>
+                <a:cs typeface="+mn-cs"/>
+              </a:defRPr>
+            </a:lvl1pPr>
+            <a:lvl2pPr marL="457200" algn="l" defTabSz="914400" rtl="0" eaLnBrk="1" latinLnBrk="0" hangingPunct="1">
+              <a:defRPr sz="1800" kern="1200">
+                <a:solidFill>
+                  <a:schemeClr val="tx1"/>
+                </a:solidFill>
+                <a:latin typeface="+mn-lt"/>
+                <a:ea typeface="+mn-ea"/>
+                <a:cs typeface="+mn-cs"/>
+              </a:defRPr>
+            </a:lvl2pPr>
+            <a:lvl3pPr marL="914400" algn="l" defTabSz="914400" rtl="0" eaLnBrk="1" latinLnBrk="0" hangingPunct="1">
+              <a:defRPr sz="1800" kern="1200">
+                <a:solidFill>
+                  <a:schemeClr val="tx1"/>
+                </a:solidFill>
+                <a:latin typeface="+mn-lt"/>
+                <a:ea typeface="+mn-ea"/>
+                <a:cs typeface="+mn-cs"/>
+              </a:defRPr>
+            </a:lvl3pPr>
+            <a:lvl4pPr marL="1371600" algn="l" defTabSz="914400" rtl="0" eaLnBrk="1" latinLnBrk="0" hangingPunct="1">
+              <a:defRPr sz="1800" kern="1200">
+                <a:solidFill>
+                  <a:schemeClr val="tx1"/>
+                </a:solidFill>
+                <a:latin typeface="+mn-lt"/>
+                <a:ea typeface="+mn-ea"/>
+                <a:cs typeface="+mn-cs"/>
+              </a:defRPr>
+            </a:lvl4pPr>
+            <a:lvl5pPr marL="1828800" algn="l" defTabSz="914400" rtl="0" eaLnBrk="1" latinLnBrk="0" hangingPunct="1">
+              <a:defRPr sz="1800" kern="1200">
+                <a:solidFill>
+                  <a:schemeClr val="tx1"/>
+                </a:solidFill>
+                <a:latin typeface="+mn-lt"/>
+                <a:ea typeface="+mn-ea"/>
+                <a:cs typeface="+mn-cs"/>
+              </a:defRPr>
+            </a:lvl5pPr>
+            <a:lvl6pPr marL="2286000" algn="l" defTabSz="914400" rtl="0" eaLnBrk="1" latinLnBrk="0" hangingPunct="1">
+              <a:defRPr sz="1800" kern="1200">
+                <a:solidFill>
+                  <a:schemeClr val="tx1"/>
+                </a:solidFill>
+                <a:latin typeface="+mn-lt"/>
+                <a:ea typeface="+mn-ea"/>
+                <a:cs typeface="+mn-cs"/>
+              </a:defRPr>
+            </a:lvl6pPr>
+            <a:lvl7pPr marL="2743200" algn="l" defTabSz="914400" rtl="0" eaLnBrk="1" latinLnBrk="0" hangingPunct="1">
+              <a:defRPr sz="1800" kern="1200">
+                <a:solidFill>
+                  <a:schemeClr val="tx1"/>
+                </a:solidFill>
+                <a:latin typeface="+mn-lt"/>
+                <a:ea typeface="+mn-ea"/>
+                <a:cs typeface="+mn-cs"/>
+              </a:defRPr>
+            </a:lvl7pPr>
+            <a:lvl8pPr marL="3200400" algn="l" defTabSz="914400" rtl="0" eaLnBrk="1" latinLnBrk="0" hangingPunct="1">
+              <a:defRPr sz="1800" kern="1200">
+                <a:solidFill>
+                  <a:schemeClr val="tx1"/>
+                </a:solidFill>
+                <a:latin typeface="+mn-lt"/>
+                <a:ea typeface="+mn-ea"/>
+                <a:cs typeface="+mn-cs"/>
+              </a:defRPr>
+            </a:lvl8pPr>
+            <a:lvl9pPr marL="3657600" algn="l" defTabSz="914400" rtl="0" eaLnBrk="1" latinLnBrk="0" hangingPunct="1">
+              <a:defRPr sz="1800" kern="1200">
+                <a:solidFill>
+                  <a:schemeClr val="tx1"/>
+                </a:solidFill>
+                <a:latin typeface="+mn-lt"/>
+                <a:ea typeface="+mn-ea"/>
+                <a:cs typeface="+mn-cs"/>
+              </a:defRPr>
+            </a:lvl9pPr>
+          </a:lstStyle>
           <a:p>
             <a:pPr marL="342900" indent="-342900" algn="l">
               <a:buFont typeface="Arial" panose="020B0604020202020204" pitchFamily="34" charset="0"/>
               <a:buChar char="•"/>
             </a:pPr>
             <a:r>
-              <a:rPr lang="en-US" sz="2000" dirty="0">
-                <a:solidFill>
-                  <a:srgbClr val="FFC000"/>
+              <a:rPr lang="en-US" sz="2400" b="1" dirty="0">
+                <a:solidFill>
+                  <a:srgbClr val="92D050"/>
                 </a:solidFill>
               </a:rPr>
-              <a:t>Pneumonia is an infection of the lungs that can cause mild to severe illness in people of all ages.</a:t>
-            </a:r>
+              <a:t>Amber </a:t>
+            </a:r>
+            <a:r>
+              <a:rPr lang="en-US" sz="2400" b="1" dirty="0" err="1">
+                <a:solidFill>
+                  <a:srgbClr val="92D050"/>
+                </a:solidFill>
+              </a:rPr>
+              <a:t>Yandow</a:t>
+            </a:r>
+            <a:endParaRPr lang="en-US" sz="2400" b="1" dirty="0">
+              <a:solidFill>
+                <a:srgbClr val="92D050"/>
+              </a:solidFill>
+            </a:endParaRPr>
           </a:p>
           <a:p>
             <a:pPr marL="342900" indent="-342900" algn="l">
@@ -20439,12 +20587,12 @@
               <a:buChar char="•"/>
             </a:pPr>
             <a:r>
-              <a:rPr lang="en-US" sz="2000" dirty="0">
-                <a:solidFill>
-                  <a:srgbClr val="FFC000"/>
+              <a:rPr lang="en-US" sz="2400" b="1" dirty="0">
+                <a:solidFill>
+                  <a:srgbClr val="92D050"/>
                 </a:solidFill>
               </a:rPr>
-              <a:t>Viruses, bacteria, and fungi can all cause pneumonia.</a:t>
+              <a:t>Ben Jacobson</a:t>
             </a:r>
           </a:p>
           <a:p>
@@ -20453,106 +20601,262 @@
               <a:buChar char="•"/>
             </a:pPr>
             <a:r>
-              <a:rPr lang="en-US" sz="2000" dirty="0">
-                <a:solidFill>
-                  <a:srgbClr val="FFC000"/>
+              <a:rPr lang="en-US" sz="2400" b="1" dirty="0" err="1">
+                <a:solidFill>
+                  <a:srgbClr val="92D050"/>
                 </a:solidFill>
               </a:rPr>
-              <a:t>Common signs of pneumonia can include cough, fever, and trouble breathing.</a:t>
-            </a:r>
-          </a:p>
-          <a:p>
-            <a:pPr algn="l"/>
-            <a:r>
-              <a:rPr lang="en-US" sz="2000" b="1" dirty="0">
-                <a:solidFill>
-                  <a:srgbClr val="FFC000"/>
+              <a:t>Luay</a:t>
+            </a:r>
+            <a:r>
+              <a:rPr lang="en-US" sz="2400" b="1" dirty="0">
+                <a:solidFill>
+                  <a:srgbClr val="92D050"/>
                 </a:solidFill>
               </a:rPr>
-              <a:t>Who can get Pneumonia:</a:t>
-            </a:r>
-          </a:p>
-          <a:p>
-            <a:pPr algn="l"/>
-            <a:r>
-              <a:rPr lang="en-US" sz="2000" dirty="0">
-                <a:solidFill>
-                  <a:srgbClr val="FFC000"/>
+              <a:t> </a:t>
+            </a:r>
+            <a:r>
+              <a:rPr lang="en-US" sz="2400" b="1" dirty="0" err="1">
+                <a:solidFill>
+                  <a:srgbClr val="92D050"/>
                 </a:solidFill>
               </a:rPr>
-              <a:t>Certain people are more likely to become ill with Pneumonia: adults 65 or older, children younger than 5 years old; people who have ongoing medical conditions (like asthma, diabetes or heart disease); and people who smoke cigarettes.</a:t>
-            </a:r>
-          </a:p>
-          <a:p>
-            <a:pPr algn="l"/>
-            <a:r>
-              <a:rPr lang="en-US" sz="2000" b="1" dirty="0">
-                <a:solidFill>
-                  <a:srgbClr val="FFC000"/>
+              <a:t>Matalka</a:t>
+            </a:r>
+            <a:endParaRPr lang="en-US" sz="2400" b="1" dirty="0">
+              <a:solidFill>
+                <a:srgbClr val="92D050"/>
+              </a:solidFill>
+            </a:endParaRPr>
+          </a:p>
+          <a:p>
+            <a:pPr marL="342900" indent="-342900" algn="l">
+              <a:buFont typeface="Arial" panose="020B0604020202020204" pitchFamily="34" charset="0"/>
+              <a:buChar char="•"/>
+            </a:pPr>
+            <a:r>
+              <a:rPr lang="en-US" sz="2400" b="1" dirty="0">
+                <a:solidFill>
+                  <a:srgbClr val="92D050"/>
                 </a:solidFill>
               </a:rPr>
-              <a:t>In the United States</a:t>
-            </a:r>
-            <a:r>
-              <a:rPr lang="en-US" sz="2000" dirty="0">
-                <a:solidFill>
-                  <a:srgbClr val="FFC000"/>
-                </a:solidFill>
-              </a:rPr>
-              <a:t>, more than 250,000 people have to seek care in a hospital due to pneumonia each year. Unfortunately, about 50,000 people die from the disease each year in the United States. Most of the people affected by pneumonia in the United States are adults.</a:t>
-            </a:r>
-          </a:p>
-        </p:txBody>
-      </p:sp>
-      <p:sp>
-        <p:nvSpPr>
-          <p:cNvPr id="5" name="Slide Number Placeholder 4">
-            <a:extLst>
-              <a:ext uri="{FF2B5EF4-FFF2-40B4-BE49-F238E27FC236}">
-                <a16:creationId xmlns:a16="http://schemas.microsoft.com/office/drawing/2014/main" id="{185B41C8-4B55-458F-878B-550AD24B15E9}"/>
-              </a:ext>
-            </a:extLst>
-          </p:cNvPr>
-          <p:cNvSpPr>
-            <a:spLocks noGrp="1"/>
-          </p:cNvSpPr>
-          <p:nvPr>
-            <p:ph type="sldNum" sz="quarter" idx="12"/>
-          </p:nvPr>
-        </p:nvSpPr>
-        <p:spPr>
-          <a:xfrm>
-            <a:off x="10779040" y="6114061"/>
-            <a:ext cx="962795" cy="251906"/>
-          </a:xfrm>
+              <a:t>Jesse Neumann</a:t>
+            </a:r>
+          </a:p>
+        </p:txBody>
+      </p:sp>
+    </p:spTree>
+    <p:extLst>
+      <p:ext uri="{BB962C8B-B14F-4D97-AF65-F5344CB8AC3E}">
+        <p14:creationId xmlns:p14="http://schemas.microsoft.com/office/powerpoint/2010/main" val="3113318487"/>
+      </p:ext>
+    </p:extLst>
+  </p:cSld>
+  <p:clrMapOvr>
+    <a:masterClrMapping/>
+  </p:clrMapOvr>
+</p:sld>
+</file>
+
+<file path=ppt/slides/slide2.xml><?xml version="1.0" encoding="utf-8"?>
+<p:sld xmlns:a="http://schemas.openxmlformats.org/drawingml/2006/main" xmlns:r="http://schemas.openxmlformats.org/officeDocument/2006/relationships" xmlns:p="http://schemas.openxmlformats.org/presentationml/2006/main">
+  <p:cSld>
+    <p:spTree>
+      <p:nvGrpSpPr>
+        <p:cNvPr id="1" name=""/>
+        <p:cNvGrpSpPr/>
+        <p:nvPr/>
+      </p:nvGrpSpPr>
+      <p:grpSpPr>
+        <a:xfrm>
+          <a:off x="0" y="0"/>
+          <a:ext cx="0" cy="0"/>
+          <a:chOff x="0" y="0"/>
+          <a:chExt cx="0" cy="0"/>
+        </a:xfrm>
+      </p:grpSpPr>
+      <p:pic>
+        <p:nvPicPr>
+          <p:cNvPr id="7" name="Picture Placeholder 6" descr="Stethescope and arms showing a medical professional taking a patient's blood pressure.  Picture includes blood pressure machine and clipboard.">
+            <a:extLst>
+              <a:ext uri="{FF2B5EF4-FFF2-40B4-BE49-F238E27FC236}">
+                <a16:creationId xmlns:a16="http://schemas.microsoft.com/office/drawing/2014/main" id="{4414D423-B276-4148-A337-5693724BB04E}"/>
+              </a:ext>
+            </a:extLst>
+          </p:cNvPr>
+          <p:cNvPicPr>
+            <a:picLocks noGrp="1" noChangeAspect="1"/>
+          </p:cNvPicPr>
+          <p:nvPr>
+            <p:ph type="pic" sz="quarter" idx="4294967295"/>
+          </p:nvPr>
+        </p:nvPicPr>
+        <p:blipFill rotWithShape="1">
+          <a:blip r:embed="rId3" cstate="screen">
+            <a:extLst>
+              <a:ext uri="{28A0092B-C50C-407E-A947-70E740481C1C}">
+                <a14:useLocalDpi xmlns:a14="http://schemas.microsoft.com/office/drawing/2010/main"/>
+              </a:ext>
+            </a:extLst>
+          </a:blip>
+          <a:srcRect/>
+          <a:stretch/>
+        </p:blipFill>
+        <p:spPr>
+          <a:xfrm>
+            <a:off x="136525" y="136525"/>
+            <a:ext cx="11909425" cy="6584950"/>
+          </a:xfrm>
+        </p:spPr>
+      </p:pic>
+      <p:sp>
+        <p:nvSpPr>
+          <p:cNvPr id="26" name="Rectangle 25">
+            <a:extLst>
+              <a:ext uri="{FF2B5EF4-FFF2-40B4-BE49-F238E27FC236}">
+                <a16:creationId xmlns:a16="http://schemas.microsoft.com/office/drawing/2014/main" id="{817B6E89-6474-4AB4-90D5-2C2FB4120F12}"/>
+              </a:ext>
+              <a:ext uri="{C183D7F6-B498-43B3-948B-1728B52AA6E4}">
+                <adec:decorative xmlns:adec="http://schemas.microsoft.com/office/drawing/2017/decorative" val="1"/>
+              </a:ext>
+            </a:extLst>
+          </p:cNvPr>
+          <p:cNvSpPr/>
+          <p:nvPr/>
+        </p:nvSpPr>
+        <p:spPr bwMode="ltGray">
+          <a:xfrm>
+            <a:off x="5573044" y="136800"/>
+            <a:ext cx="6482430" cy="6584675"/>
+          </a:xfrm>
+          <a:prstGeom prst="rect">
+            <a:avLst/>
+          </a:prstGeom>
+          <a:solidFill>
+            <a:schemeClr val="accent4">
+              <a:alpha val="90000"/>
+            </a:schemeClr>
+          </a:solidFill>
           <a:ln>
             <a:noFill/>
           </a:ln>
         </p:spPr>
+        <p:style>
+          <a:lnRef idx="2">
+            <a:schemeClr val="accent1">
+              <a:shade val="50000"/>
+            </a:schemeClr>
+          </a:lnRef>
+          <a:fillRef idx="1">
+            <a:schemeClr val="accent1"/>
+          </a:fillRef>
+          <a:effectRef idx="0">
+            <a:schemeClr val="accent1"/>
+          </a:effectRef>
+          <a:fontRef idx="minor">
+            <a:schemeClr val="lt1"/>
+          </a:fontRef>
+        </p:style>
+        <p:txBody>
+          <a:bodyPr rtlCol="0" anchor="ctr"/>
+          <a:lstStyle/>
+          <a:p>
+            <a:pPr algn="ctr"/>
+            <a:endParaRPr lang="en-US" dirty="0"/>
+          </a:p>
+        </p:txBody>
+      </p:sp>
+      <p:sp>
+        <p:nvSpPr>
+          <p:cNvPr id="2" name="Title 1">
+            <a:extLst>
+              <a:ext uri="{FF2B5EF4-FFF2-40B4-BE49-F238E27FC236}">
+                <a16:creationId xmlns:a16="http://schemas.microsoft.com/office/drawing/2014/main" id="{E52BFEB6-F40E-4219-9AA6-8A27C2E8899B}"/>
+              </a:ext>
+            </a:extLst>
+          </p:cNvPr>
+          <p:cNvSpPr>
+            <a:spLocks noGrp="1"/>
+          </p:cNvSpPr>
+          <p:nvPr>
+            <p:ph type="ctrTitle"/>
+          </p:nvPr>
+        </p:nvSpPr>
+        <p:spPr bwMode="black">
+          <a:xfrm>
+            <a:off x="5375348" y="639515"/>
+            <a:ext cx="5813554" cy="1341822"/>
+          </a:xfrm>
+        </p:spPr>
         <p:txBody>
           <a:bodyPr/>
           <a:lstStyle/>
           <a:p>
-            <a:r>
-              <a:rPr lang="en-US" dirty="0">
-                <a:solidFill>
-                  <a:schemeClr val="bg1"/>
+            <a:pPr algn="ctr"/>
+            <a:r>
+              <a:rPr lang="en-US" b="1" dirty="0"/>
+              <a:t>Pneumonia Detection</a:t>
+            </a:r>
+            <a:br>
+              <a:rPr lang="en-US" b="1" dirty="0"/>
+            </a:br>
+            <a:r>
+              <a:rPr lang="en-US" b="1" dirty="0"/>
+              <a:t>CNN classifier</a:t>
+            </a:r>
+          </a:p>
+        </p:txBody>
+      </p:sp>
+      <p:sp>
+        <p:nvSpPr>
+          <p:cNvPr id="3" name="Subtitle 2">
+            <a:extLst>
+              <a:ext uri="{FF2B5EF4-FFF2-40B4-BE49-F238E27FC236}">
+                <a16:creationId xmlns:a16="http://schemas.microsoft.com/office/drawing/2014/main" id="{74DB1EEC-D590-4C80-ABB7-362BBE1F5A1B}"/>
+              </a:ext>
+            </a:extLst>
+          </p:cNvPr>
+          <p:cNvSpPr>
+            <a:spLocks noGrp="1"/>
+          </p:cNvSpPr>
+          <p:nvPr>
+            <p:ph type="subTitle" idx="1"/>
+          </p:nvPr>
+        </p:nvSpPr>
+        <p:spPr bwMode="black">
+          <a:xfrm>
+            <a:off x="7863673" y="5273673"/>
+            <a:ext cx="3161882" cy="1341821"/>
+          </a:xfrm>
+        </p:spPr>
+        <p:txBody>
+          <a:bodyPr/>
+          <a:lstStyle/>
+          <a:p>
+            <a:pPr algn="ctr"/>
+            <a:r>
+              <a:rPr lang="en-US" b="1" dirty="0">
+                <a:solidFill>
+                  <a:srgbClr val="FFC000"/>
                 </a:solidFill>
               </a:rPr>
-              <a:t>page </a:t>
-            </a:r>
-            <a:fld id="{19B51A1E-902D-48AF-9020-955120F399B6}" type="slidenum">
-              <a:rPr lang="en-US" smtClean="0">
-                <a:solidFill>
-                  <a:schemeClr val="bg1"/>
+              <a:t>By  Chamila Dharmawardhana</a:t>
+            </a:r>
+          </a:p>
+          <a:p>
+            <a:pPr algn="ctr"/>
+            <a:r>
+              <a:rPr lang="en-US" b="1" dirty="0">
+                <a:solidFill>
+                  <a:srgbClr val="FFC000"/>
                 </a:solidFill>
               </a:rPr>
-              <a:pPr/>
-              <a:t>2</a:t>
-            </a:fld>
+              <a:t>Vidya Menon</a:t>
+            </a:r>
             <a:endParaRPr lang="en-US" dirty="0">
               <a:solidFill>
-                <a:schemeClr val="bg1"/>
+                <a:srgbClr val="FFC000"/>
               </a:solidFill>
             </a:endParaRPr>
           </a:p>
@@ -20560,55 +20864,262 @@
       </p:sp>
       <p:pic>
         <p:nvPicPr>
-          <p:cNvPr id="6" name="Picture 2">
-            <a:extLst>
-              <a:ext uri="{FF2B5EF4-FFF2-40B4-BE49-F238E27FC236}">
-                <a16:creationId xmlns:a16="http://schemas.microsoft.com/office/drawing/2014/main" id="{38615E6B-DF63-4F25-A287-79D01E2E773A}"/>
+          <p:cNvPr id="5" name="Picture 4" descr="A picture containing film, indoor, sitting, person&#10;&#10;Description automatically generated">
+            <a:extLst>
+              <a:ext uri="{FF2B5EF4-FFF2-40B4-BE49-F238E27FC236}">
+                <a16:creationId xmlns:a16="http://schemas.microsoft.com/office/drawing/2014/main" id="{6E680686-2EDB-43AB-8497-12F4671F4118}"/>
               </a:ext>
             </a:extLst>
           </p:cNvPr>
           <p:cNvPicPr>
-            <a:picLocks noChangeAspect="1" noChangeArrowheads="1"/>
+            <a:picLocks noChangeAspect="1"/>
           </p:cNvPicPr>
           <p:nvPr/>
         </p:nvPicPr>
         <p:blipFill>
-          <a:blip r:embed="rId3">
-            <a:extLst>
-              <a:ext uri="{28A0092B-C50C-407E-A947-70E740481C1C}">
-                <a14:useLocalDpi xmlns:a14="http://schemas.microsoft.com/office/drawing/2010/main" val="0"/>
-              </a:ext>
-            </a:extLst>
-          </a:blip>
-          <a:srcRect/>
+          <a:blip r:embed="rId4"/>
           <a:stretch>
             <a:fillRect/>
           </a:stretch>
         </p:blipFill>
-        <p:spPr bwMode="auto">
-          <a:xfrm>
-            <a:off x="7793501" y="1212033"/>
-            <a:ext cx="4067050" cy="4902028"/>
+        <p:spPr>
+          <a:xfrm>
+            <a:off x="146050" y="136526"/>
+            <a:ext cx="5452511" cy="6603626"/>
           </a:xfrm>
           <a:prstGeom prst="rect">
             <a:avLst/>
           </a:prstGeom>
-          <a:noFill/>
-          <a:extLst>
-            <a:ext uri="{909E8E84-426E-40DD-AFC4-6F175D3DCCD1}">
-              <a14:hiddenFill xmlns:a14="http://schemas.microsoft.com/office/drawing/2010/main">
-                <a:solidFill>
-                  <a:srgbClr val="FFFFFF"/>
-                </a:solidFill>
-              </a14:hiddenFill>
-            </a:ext>
-          </a:extLst>
         </p:spPr>
       </p:pic>
+      <p:sp>
+        <p:nvSpPr>
+          <p:cNvPr id="9" name="Subtitle 2">
+            <a:extLst>
+              <a:ext uri="{FF2B5EF4-FFF2-40B4-BE49-F238E27FC236}">
+                <a16:creationId xmlns:a16="http://schemas.microsoft.com/office/drawing/2014/main" id="{7D37EB24-A4F1-41F2-9C1E-8FAF77E61354}"/>
+              </a:ext>
+            </a:extLst>
+          </p:cNvPr>
+          <p:cNvSpPr txBox="1">
+            <a:spLocks/>
+          </p:cNvSpPr>
+          <p:nvPr/>
+        </p:nvSpPr>
+        <p:spPr bwMode="black">
+          <a:xfrm>
+            <a:off x="5615739" y="2484052"/>
+            <a:ext cx="5657850" cy="2882032"/>
+          </a:xfrm>
+          <a:prstGeom prst="rect">
+            <a:avLst/>
+          </a:prstGeom>
+        </p:spPr>
+        <p:txBody>
+          <a:bodyPr vert="horz" lIns="0" tIns="0" rIns="0" bIns="0" rtlCol="0">
+            <a:noAutofit/>
+          </a:bodyPr>
+          <a:lstStyle>
+            <a:lvl1pPr marL="0" indent="0" algn="r" defTabSz="914400" rtl="0" eaLnBrk="1" latinLnBrk="0" hangingPunct="1">
+              <a:lnSpc>
+                <a:spcPct val="90000"/>
+              </a:lnSpc>
+              <a:spcBef>
+                <a:spcPts val="1000"/>
+              </a:spcBef>
+              <a:buFont typeface="Arial" panose="020B0604020202020204" pitchFamily="34" charset="0"/>
+              <a:buNone/>
+              <a:defRPr sz="2400" kern="1200">
+                <a:solidFill>
+                  <a:schemeClr val="bg1"/>
+                </a:solidFill>
+                <a:latin typeface="+mn-lt"/>
+                <a:ea typeface="+mn-ea"/>
+                <a:cs typeface="+mn-cs"/>
+              </a:defRPr>
+            </a:lvl1pPr>
+            <a:lvl2pPr marL="457200" indent="0" algn="ctr" defTabSz="914400" rtl="0" eaLnBrk="1" latinLnBrk="0" hangingPunct="1">
+              <a:lnSpc>
+                <a:spcPct val="90000"/>
+              </a:lnSpc>
+              <a:spcBef>
+                <a:spcPts val="500"/>
+              </a:spcBef>
+              <a:buFont typeface="Arial" panose="020B0604020202020204" pitchFamily="34" charset="0"/>
+              <a:buNone/>
+              <a:defRPr sz="2000" kern="1200">
+                <a:solidFill>
+                  <a:schemeClr val="tx1">
+                    <a:lumMod val="75000"/>
+                    <a:lumOff val="25000"/>
+                  </a:schemeClr>
+                </a:solidFill>
+                <a:latin typeface="+mn-lt"/>
+                <a:ea typeface="+mn-ea"/>
+                <a:cs typeface="+mn-cs"/>
+              </a:defRPr>
+            </a:lvl2pPr>
+            <a:lvl3pPr marL="914400" indent="0" algn="ctr" defTabSz="914400" rtl="0" eaLnBrk="1" latinLnBrk="0" hangingPunct="1">
+              <a:lnSpc>
+                <a:spcPct val="90000"/>
+              </a:lnSpc>
+              <a:spcBef>
+                <a:spcPts val="500"/>
+              </a:spcBef>
+              <a:buFont typeface="Arial" panose="020B0604020202020204" pitchFamily="34" charset="0"/>
+              <a:buNone/>
+              <a:defRPr sz="1800" kern="1200">
+                <a:solidFill>
+                  <a:schemeClr val="tx1">
+                    <a:lumMod val="75000"/>
+                    <a:lumOff val="25000"/>
+                  </a:schemeClr>
+                </a:solidFill>
+                <a:latin typeface="+mn-lt"/>
+                <a:ea typeface="+mn-ea"/>
+                <a:cs typeface="+mn-cs"/>
+              </a:defRPr>
+            </a:lvl3pPr>
+            <a:lvl4pPr marL="1371600" indent="0" algn="ctr" defTabSz="914400" rtl="0" eaLnBrk="1" latinLnBrk="0" hangingPunct="1">
+              <a:lnSpc>
+                <a:spcPct val="90000"/>
+              </a:lnSpc>
+              <a:spcBef>
+                <a:spcPts val="500"/>
+              </a:spcBef>
+              <a:buFont typeface="Arial" panose="020B0604020202020204" pitchFamily="34" charset="0"/>
+              <a:buNone/>
+              <a:defRPr sz="1600" kern="1200">
+                <a:solidFill>
+                  <a:schemeClr val="tx1">
+                    <a:lumMod val="75000"/>
+                    <a:lumOff val="25000"/>
+                  </a:schemeClr>
+                </a:solidFill>
+                <a:latin typeface="+mn-lt"/>
+                <a:ea typeface="+mn-ea"/>
+                <a:cs typeface="+mn-cs"/>
+              </a:defRPr>
+            </a:lvl4pPr>
+            <a:lvl5pPr marL="1828800" indent="0" algn="ctr" defTabSz="914400" rtl="0" eaLnBrk="1" latinLnBrk="0" hangingPunct="1">
+              <a:lnSpc>
+                <a:spcPct val="90000"/>
+              </a:lnSpc>
+              <a:spcBef>
+                <a:spcPts val="500"/>
+              </a:spcBef>
+              <a:buFont typeface="Arial" panose="020B0604020202020204" pitchFamily="34" charset="0"/>
+              <a:buNone/>
+              <a:defRPr sz="1600" kern="1200">
+                <a:solidFill>
+                  <a:schemeClr val="tx1">
+                    <a:lumMod val="75000"/>
+                    <a:lumOff val="25000"/>
+                  </a:schemeClr>
+                </a:solidFill>
+                <a:latin typeface="+mn-lt"/>
+                <a:ea typeface="+mn-ea"/>
+                <a:cs typeface="+mn-cs"/>
+              </a:defRPr>
+            </a:lvl5pPr>
+            <a:lvl6pPr marL="2286000" indent="0" algn="ctr" defTabSz="914400" rtl="0" eaLnBrk="1" latinLnBrk="0" hangingPunct="1">
+              <a:lnSpc>
+                <a:spcPct val="90000"/>
+              </a:lnSpc>
+              <a:spcBef>
+                <a:spcPts val="500"/>
+              </a:spcBef>
+              <a:buFont typeface="Arial" panose="020B0604020202020204" pitchFamily="34" charset="0"/>
+              <a:buNone/>
+              <a:defRPr sz="1600" kern="1200">
+                <a:solidFill>
+                  <a:schemeClr val="tx1"/>
+                </a:solidFill>
+                <a:latin typeface="+mn-lt"/>
+                <a:ea typeface="+mn-ea"/>
+                <a:cs typeface="+mn-cs"/>
+              </a:defRPr>
+            </a:lvl6pPr>
+            <a:lvl7pPr marL="2743200" indent="0" algn="ctr" defTabSz="914400" rtl="0" eaLnBrk="1" latinLnBrk="0" hangingPunct="1">
+              <a:lnSpc>
+                <a:spcPct val="90000"/>
+              </a:lnSpc>
+              <a:spcBef>
+                <a:spcPts val="500"/>
+              </a:spcBef>
+              <a:buFont typeface="Arial" panose="020B0604020202020204" pitchFamily="34" charset="0"/>
+              <a:buNone/>
+              <a:defRPr sz="1600" kern="1200">
+                <a:solidFill>
+                  <a:schemeClr val="tx1"/>
+                </a:solidFill>
+                <a:latin typeface="+mn-lt"/>
+                <a:ea typeface="+mn-ea"/>
+                <a:cs typeface="+mn-cs"/>
+              </a:defRPr>
+            </a:lvl7pPr>
+            <a:lvl8pPr marL="3200400" indent="0" algn="ctr" defTabSz="914400" rtl="0" eaLnBrk="1" latinLnBrk="0" hangingPunct="1">
+              <a:lnSpc>
+                <a:spcPct val="90000"/>
+              </a:lnSpc>
+              <a:spcBef>
+                <a:spcPts val="500"/>
+              </a:spcBef>
+              <a:buFont typeface="Arial" panose="020B0604020202020204" pitchFamily="34" charset="0"/>
+              <a:buNone/>
+              <a:defRPr sz="1600" kern="1200">
+                <a:solidFill>
+                  <a:schemeClr val="tx1"/>
+                </a:solidFill>
+                <a:latin typeface="+mn-lt"/>
+                <a:ea typeface="+mn-ea"/>
+                <a:cs typeface="+mn-cs"/>
+              </a:defRPr>
+            </a:lvl8pPr>
+            <a:lvl9pPr marL="3657600" indent="0" algn="ctr" defTabSz="914400" rtl="0" eaLnBrk="1" latinLnBrk="0" hangingPunct="1">
+              <a:lnSpc>
+                <a:spcPct val="90000"/>
+              </a:lnSpc>
+              <a:spcBef>
+                <a:spcPts val="500"/>
+              </a:spcBef>
+              <a:buFont typeface="Arial" panose="020B0604020202020204" pitchFamily="34" charset="0"/>
+              <a:buNone/>
+              <a:defRPr sz="1600" kern="1200">
+                <a:solidFill>
+                  <a:schemeClr val="tx1"/>
+                </a:solidFill>
+                <a:latin typeface="+mn-lt"/>
+                <a:ea typeface="+mn-ea"/>
+                <a:cs typeface="+mn-cs"/>
+              </a:defRPr>
+            </a:lvl9pPr>
+          </a:lstStyle>
+          <a:p>
+            <a:pPr algn="l"/>
+            <a:r>
+              <a:rPr lang="en-US" b="1" dirty="0"/>
+              <a:t>About:</a:t>
+            </a:r>
+          </a:p>
+          <a:p>
+            <a:pPr algn="l"/>
+            <a:r>
+              <a:rPr lang="en-US" dirty="0"/>
+              <a:t>This blog outlines building a Convolutional Neural Network (CNN)  to detect Pneumonia from chest X_ray of any patient. </a:t>
+            </a:r>
+            <a:endParaRPr lang="en-US" b="1" dirty="0"/>
+          </a:p>
+          <a:p>
+            <a:pPr algn="just"/>
+            <a:endParaRPr lang="en-US" dirty="0"/>
+          </a:p>
+        </p:txBody>
+      </p:sp>
     </p:spTree>
     <p:extLst>
       <p:ext uri="{BB962C8B-B14F-4D97-AF65-F5344CB8AC3E}">
-        <p14:creationId xmlns:p14="http://schemas.microsoft.com/office/powerpoint/2010/main" val="4062936799"/>
+        <p14:creationId xmlns:p14="http://schemas.microsoft.com/office/powerpoint/2010/main" val="2848105078"/>
       </p:ext>
     </p:extLst>
   </p:cSld>
@@ -20635,48 +21146,12 @@
           <a:chExt cx="0" cy="0"/>
         </a:xfrm>
       </p:grpSpPr>
-      <p:pic>
-        <p:nvPicPr>
-          <p:cNvPr id="8" name="Picture Placeholder 7" descr="Arial image of table with medical instruments, medicine, a clipboard, and other medical equipment">
-            <a:extLst>
-              <a:ext uri="{FF2B5EF4-FFF2-40B4-BE49-F238E27FC236}">
-                <a16:creationId xmlns:a16="http://schemas.microsoft.com/office/drawing/2014/main" id="{0A756A3F-0F08-4577-8E72-1E643EFB097C}"/>
-              </a:ext>
-            </a:extLst>
-          </p:cNvPr>
-          <p:cNvPicPr>
-            <a:picLocks noGrp="1" noChangeAspect="1"/>
-          </p:cNvPicPr>
-          <p:nvPr>
-            <p:ph type="pic" sz="quarter" idx="4294967295"/>
-          </p:nvPr>
-        </p:nvPicPr>
-        <p:blipFill>
-          <a:blip r:embed="rId3" cstate="screen">
-            <a:extLst>
-              <a:ext uri="{28A0092B-C50C-407E-A947-70E740481C1C}">
-                <a14:useLocalDpi xmlns:a14="http://schemas.microsoft.com/office/drawing/2010/main"/>
-              </a:ext>
-            </a:extLst>
-          </a:blip>
-          <a:srcRect/>
-          <a:stretch>
-            <a:fillRect/>
-          </a:stretch>
-        </p:blipFill>
-        <p:spPr>
-          <a:xfrm>
-            <a:off x="294427" y="351692"/>
-            <a:ext cx="5582174" cy="6020265"/>
-          </a:xfrm>
-        </p:spPr>
-      </p:pic>
-      <p:sp>
-        <p:nvSpPr>
-          <p:cNvPr id="18" name="Rectangle 17">
-            <a:extLst>
-              <a:ext uri="{FF2B5EF4-FFF2-40B4-BE49-F238E27FC236}">
-                <a16:creationId xmlns:a16="http://schemas.microsoft.com/office/drawing/2014/main" id="{75F2B1C5-78F6-4A28-8883-7C500ADCB7D4}"/>
+      <p:sp>
+        <p:nvSpPr>
+          <p:cNvPr id="9" name="Rectangle 8">
+            <a:extLst>
+              <a:ext uri="{FF2B5EF4-FFF2-40B4-BE49-F238E27FC236}">
+                <a16:creationId xmlns:a16="http://schemas.microsoft.com/office/drawing/2014/main" id="{670550D9-B72F-46D0-B3A1-179DADF002AC}"/>
               </a:ext>
               <a:ext uri="{C183D7F6-B498-43B3-948B-1728B52AA6E4}">
                 <adec:decorative xmlns:adec="http://schemas.microsoft.com/office/drawing/2017/decorative" val="1"/>
@@ -20688,8 +21163,8 @@
         </p:nvSpPr>
         <p:spPr bwMode="invGray">
           <a:xfrm rot="5400000">
-            <a:off x="5876954" y="351340"/>
-            <a:ext cx="6020266" cy="6020972"/>
+            <a:off x="2885104" y="-2512258"/>
+            <a:ext cx="6421793" cy="11882516"/>
           </a:xfrm>
           <a:prstGeom prst="rect">
             <a:avLst/>
@@ -20730,10 +21205,10 @@
       </p:sp>
       <p:sp>
         <p:nvSpPr>
-          <p:cNvPr id="2" name="Title 1">
-            <a:extLst>
-              <a:ext uri="{FF2B5EF4-FFF2-40B4-BE49-F238E27FC236}">
-                <a16:creationId xmlns:a16="http://schemas.microsoft.com/office/drawing/2014/main" id="{B35ED38B-2505-420A-A14A-D41E71EDBA33}"/>
+          <p:cNvPr id="3" name="Title 2">
+            <a:extLst>
+              <a:ext uri="{FF2B5EF4-FFF2-40B4-BE49-F238E27FC236}">
+                <a16:creationId xmlns:a16="http://schemas.microsoft.com/office/drawing/2014/main" id="{7A663105-4B92-4F24-9DF6-58BB116E29FA}"/>
               </a:ext>
             </a:extLst>
           </p:cNvPr>
@@ -20746,8 +21221,8 @@
         </p:nvSpPr>
         <p:spPr bwMode="black">
           <a:xfrm>
-            <a:off x="6957824" y="902486"/>
-            <a:ext cx="3530583" cy="1252433"/>
+            <a:off x="3328800" y="492033"/>
+            <a:ext cx="5085650" cy="720000"/>
           </a:xfrm>
         </p:spPr>
         <p:txBody>
@@ -20756,17 +21231,17 @@
           <a:p>
             <a:r>
               <a:rPr lang="en-US" b="1" dirty="0"/>
-              <a:t>  The Challenge</a:t>
-            </a:r>
-          </a:p>
-        </p:txBody>
-      </p:sp>
-      <p:sp>
-        <p:nvSpPr>
-          <p:cNvPr id="3" name="Subtitle 2">
-            <a:extLst>
-              <a:ext uri="{FF2B5EF4-FFF2-40B4-BE49-F238E27FC236}">
-                <a16:creationId xmlns:a16="http://schemas.microsoft.com/office/drawing/2014/main" id="{71F217F2-8C36-4584-BD5D-0B00606DF9A2}"/>
+              <a:t>About Pneumonia</a:t>
+            </a:r>
+          </a:p>
+        </p:txBody>
+      </p:sp>
+      <p:sp>
+        <p:nvSpPr>
+          <p:cNvPr id="4" name="Subtitle 3">
+            <a:extLst>
+              <a:ext uri="{FF2B5EF4-FFF2-40B4-BE49-F238E27FC236}">
+                <a16:creationId xmlns:a16="http://schemas.microsoft.com/office/drawing/2014/main" id="{8E41F722-BA6E-4DCA-864E-876ECDFB5336}"/>
               </a:ext>
             </a:extLst>
           </p:cNvPr>
@@ -20779,49 +21254,115 @@
         </p:nvSpPr>
         <p:spPr bwMode="black">
           <a:xfrm>
-            <a:off x="6473312" y="2384075"/>
-            <a:ext cx="5085650" cy="2363129"/>
+            <a:off x="450165" y="1212033"/>
+            <a:ext cx="7166628" cy="5153934"/>
           </a:xfrm>
         </p:spPr>
         <p:txBody>
           <a:bodyPr/>
           <a:lstStyle/>
           <a:p>
-            <a:pPr algn="ctr"/>
-            <a:r>
-              <a:rPr lang="en-US" dirty="0">
-                <a:solidFill>
-                  <a:schemeClr val="accent1">
-                    <a:lumMod val="60000"/>
-                    <a:lumOff val="40000"/>
-                  </a:schemeClr>
+            <a:pPr algn="l"/>
+            <a:r>
+              <a:rPr lang="en-US" sz="2000" b="1" dirty="0">
+                <a:solidFill>
+                  <a:srgbClr val="FFC000"/>
                 </a:solidFill>
               </a:rPr>
-              <a:t>Build an algorithm to identify whether a patient is suffering from pneumonia or not, by looking at chest X-ray images.</a:t>
-            </a:r>
-          </a:p>
-          <a:p>
-            <a:pPr algn="ctr"/>
-            <a:r>
-              <a:rPr lang="en-US" dirty="0">
-                <a:solidFill>
-                  <a:schemeClr val="accent1">
-                    <a:lumMod val="60000"/>
-                    <a:lumOff val="40000"/>
-                  </a:schemeClr>
+              <a:t>Key Facts:</a:t>
+            </a:r>
+          </a:p>
+          <a:p>
+            <a:pPr marL="342900" indent="-342900" algn="l">
+              <a:buFont typeface="Arial" panose="020B0604020202020204" pitchFamily="34" charset="0"/>
+              <a:buChar char="•"/>
+            </a:pPr>
+            <a:r>
+              <a:rPr lang="en-US" sz="2000" dirty="0">
+                <a:solidFill>
+                  <a:srgbClr val="FFC000"/>
                 </a:solidFill>
               </a:rPr>
-              <a:t> The algorithm must be extremely accurate because lives of people is at stake.</a:t>
-            </a:r>
-          </a:p>
-        </p:txBody>
-      </p:sp>
-      <p:sp>
-        <p:nvSpPr>
-          <p:cNvPr id="23" name="Slide Number Placeholder 22">
-            <a:extLst>
-              <a:ext uri="{FF2B5EF4-FFF2-40B4-BE49-F238E27FC236}">
-                <a16:creationId xmlns:a16="http://schemas.microsoft.com/office/drawing/2014/main" id="{4D5E33D6-D847-4F4C-BA8B-75CB853FAB76}"/>
+              <a:t>Pneumonia is an infection of the lungs that can cause mild to severe illness in people of all ages.</a:t>
+            </a:r>
+          </a:p>
+          <a:p>
+            <a:pPr marL="342900" indent="-342900" algn="l">
+              <a:buFont typeface="Arial" panose="020B0604020202020204" pitchFamily="34" charset="0"/>
+              <a:buChar char="•"/>
+            </a:pPr>
+            <a:r>
+              <a:rPr lang="en-US" sz="2000" dirty="0">
+                <a:solidFill>
+                  <a:srgbClr val="FFC000"/>
+                </a:solidFill>
+              </a:rPr>
+              <a:t>Viruses, bacteria, and fungi can all cause pneumonia.</a:t>
+            </a:r>
+          </a:p>
+          <a:p>
+            <a:pPr marL="342900" indent="-342900" algn="l">
+              <a:buFont typeface="Arial" panose="020B0604020202020204" pitchFamily="34" charset="0"/>
+              <a:buChar char="•"/>
+            </a:pPr>
+            <a:r>
+              <a:rPr lang="en-US" sz="2000" dirty="0">
+                <a:solidFill>
+                  <a:srgbClr val="FFC000"/>
+                </a:solidFill>
+              </a:rPr>
+              <a:t>Common signs of pneumonia can include cough, fever, and trouble breathing.</a:t>
+            </a:r>
+          </a:p>
+          <a:p>
+            <a:pPr algn="l"/>
+            <a:r>
+              <a:rPr lang="en-US" sz="2000" b="1" dirty="0">
+                <a:solidFill>
+                  <a:srgbClr val="FFC000"/>
+                </a:solidFill>
+              </a:rPr>
+              <a:t>Who can get Pneumonia:</a:t>
+            </a:r>
+          </a:p>
+          <a:p>
+            <a:pPr algn="l"/>
+            <a:r>
+              <a:rPr lang="en-US" sz="2000" dirty="0">
+                <a:solidFill>
+                  <a:srgbClr val="FFC000"/>
+                </a:solidFill>
+              </a:rPr>
+              <a:t>Certain people are more likely to become ill with Pneumonia: adults 65 or older, children younger than 5 years old; people who have ongoing medical conditions (like asthma, diabetes or heart disease); and people who smoke cigarettes.</a:t>
+            </a:r>
+          </a:p>
+          <a:p>
+            <a:pPr algn="l"/>
+            <a:r>
+              <a:rPr lang="en-US" sz="2000" b="1" dirty="0">
+                <a:solidFill>
+                  <a:srgbClr val="FFC000"/>
+                </a:solidFill>
+              </a:rPr>
+              <a:t>In the United States</a:t>
+            </a:r>
+            <a:r>
+              <a:rPr lang="en-US" sz="2000" dirty="0">
+                <a:solidFill>
+                  <a:srgbClr val="FFC000"/>
+                </a:solidFill>
+              </a:rPr>
+              <a:t>, more than 250,000 people have to seek care in a hospital due to pneumonia each year. Unfortunately, about 50,000 people die from the disease each year in the United States. Most of the people affected by pneumonia in the United States are adults.</a:t>
+            </a:r>
+          </a:p>
+        </p:txBody>
+      </p:sp>
+      <p:sp>
+        <p:nvSpPr>
+          <p:cNvPr id="5" name="Slide Number Placeholder 4">
+            <a:extLst>
+              <a:ext uri="{FF2B5EF4-FFF2-40B4-BE49-F238E27FC236}">
+                <a16:creationId xmlns:a16="http://schemas.microsoft.com/office/drawing/2014/main" id="{185B41C8-4B55-458F-878B-550AD24B15E9}"/>
               </a:ext>
             </a:extLst>
           </p:cNvPr>
@@ -20834,8 +21375,8 @@
         </p:nvSpPr>
         <p:spPr>
           <a:xfrm>
-            <a:off x="11077565" y="6371957"/>
-            <a:ext cx="962795" cy="264330"/>
+            <a:off x="10779040" y="6114061"/>
+            <a:ext cx="962795" cy="251906"/>
           </a:xfrm>
           <a:ln>
             <a:noFill/>
@@ -20870,10 +21411,57 @@
           </a:p>
         </p:txBody>
       </p:sp>
+      <p:pic>
+        <p:nvPicPr>
+          <p:cNvPr id="6" name="Picture 2">
+            <a:extLst>
+              <a:ext uri="{FF2B5EF4-FFF2-40B4-BE49-F238E27FC236}">
+                <a16:creationId xmlns:a16="http://schemas.microsoft.com/office/drawing/2014/main" id="{38615E6B-DF63-4F25-A287-79D01E2E773A}"/>
+              </a:ext>
+            </a:extLst>
+          </p:cNvPr>
+          <p:cNvPicPr>
+            <a:picLocks noChangeAspect="1" noChangeArrowheads="1"/>
+          </p:cNvPicPr>
+          <p:nvPr/>
+        </p:nvPicPr>
+        <p:blipFill>
+          <a:blip r:embed="rId3">
+            <a:extLst>
+              <a:ext uri="{28A0092B-C50C-407E-A947-70E740481C1C}">
+                <a14:useLocalDpi xmlns:a14="http://schemas.microsoft.com/office/drawing/2010/main" val="0"/>
+              </a:ext>
+            </a:extLst>
+          </a:blip>
+          <a:srcRect/>
+          <a:stretch>
+            <a:fillRect/>
+          </a:stretch>
+        </p:blipFill>
+        <p:spPr bwMode="auto">
+          <a:xfrm>
+            <a:off x="7793501" y="1212033"/>
+            <a:ext cx="4067050" cy="4902028"/>
+          </a:xfrm>
+          <a:prstGeom prst="rect">
+            <a:avLst/>
+          </a:prstGeom>
+          <a:noFill/>
+          <a:extLst>
+            <a:ext uri="{909E8E84-426E-40DD-AFC4-6F175D3DCCD1}">
+              <a14:hiddenFill xmlns:a14="http://schemas.microsoft.com/office/drawing/2010/main">
+                <a:solidFill>
+                  <a:srgbClr val="FFFFFF"/>
+                </a:solidFill>
+              </a14:hiddenFill>
+            </a:ext>
+          </a:extLst>
+        </p:spPr>
+      </p:pic>
     </p:spTree>
     <p:extLst>
       <p:ext uri="{BB962C8B-B14F-4D97-AF65-F5344CB8AC3E}">
-        <p14:creationId xmlns:p14="http://schemas.microsoft.com/office/powerpoint/2010/main" val="909226357"/>
+        <p14:creationId xmlns:p14="http://schemas.microsoft.com/office/powerpoint/2010/main" val="4062936799"/>
       </p:ext>
     </p:extLst>
   </p:cSld>
@@ -20900,12 +21488,48 @@
           <a:chExt cx="0" cy="0"/>
         </a:xfrm>
       </p:grpSpPr>
-      <p:sp>
-        <p:nvSpPr>
-          <p:cNvPr id="9" name="Rectangle 8">
-            <a:extLst>
-              <a:ext uri="{FF2B5EF4-FFF2-40B4-BE49-F238E27FC236}">
-                <a16:creationId xmlns:a16="http://schemas.microsoft.com/office/drawing/2014/main" id="{670550D9-B72F-46D0-B3A1-179DADF002AC}"/>
+      <p:pic>
+        <p:nvPicPr>
+          <p:cNvPr id="8" name="Picture Placeholder 7" descr="Arial image of table with medical instruments, medicine, a clipboard, and other medical equipment">
+            <a:extLst>
+              <a:ext uri="{FF2B5EF4-FFF2-40B4-BE49-F238E27FC236}">
+                <a16:creationId xmlns:a16="http://schemas.microsoft.com/office/drawing/2014/main" id="{0A756A3F-0F08-4577-8E72-1E643EFB097C}"/>
+              </a:ext>
+            </a:extLst>
+          </p:cNvPr>
+          <p:cNvPicPr>
+            <a:picLocks noGrp="1" noChangeAspect="1"/>
+          </p:cNvPicPr>
+          <p:nvPr>
+            <p:ph type="pic" sz="quarter" idx="4294967295"/>
+          </p:nvPr>
+        </p:nvPicPr>
+        <p:blipFill>
+          <a:blip r:embed="rId3" cstate="screen">
+            <a:extLst>
+              <a:ext uri="{28A0092B-C50C-407E-A947-70E740481C1C}">
+                <a14:useLocalDpi xmlns:a14="http://schemas.microsoft.com/office/drawing/2010/main"/>
+              </a:ext>
+            </a:extLst>
+          </a:blip>
+          <a:srcRect/>
+          <a:stretch>
+            <a:fillRect/>
+          </a:stretch>
+        </p:blipFill>
+        <p:spPr>
+          <a:xfrm>
+            <a:off x="294427" y="351692"/>
+            <a:ext cx="5582174" cy="6020265"/>
+          </a:xfrm>
+        </p:spPr>
+      </p:pic>
+      <p:sp>
+        <p:nvSpPr>
+          <p:cNvPr id="18" name="Rectangle 17">
+            <a:extLst>
+              <a:ext uri="{FF2B5EF4-FFF2-40B4-BE49-F238E27FC236}">
+                <a16:creationId xmlns:a16="http://schemas.microsoft.com/office/drawing/2014/main" id="{75F2B1C5-78F6-4A28-8883-7C500ADCB7D4}"/>
               </a:ext>
               <a:ext uri="{C183D7F6-B498-43B3-948B-1728B52AA6E4}">
                 <adec:decorative xmlns:adec="http://schemas.microsoft.com/office/drawing/2017/decorative" val="1"/>
@@ -20917,8 +21541,8 @@
         </p:nvSpPr>
         <p:spPr bwMode="invGray">
           <a:xfrm rot="5400000">
-            <a:off x="2741314" y="-2528060"/>
-            <a:ext cx="6687139" cy="11914120"/>
+            <a:off x="5876954" y="351340"/>
+            <a:ext cx="6020266" cy="6020972"/>
           </a:xfrm>
           <a:prstGeom prst="rect">
             <a:avLst/>
@@ -20959,10 +21583,10 @@
       </p:sp>
       <p:sp>
         <p:nvSpPr>
-          <p:cNvPr id="3" name="Title 2">
-            <a:extLst>
-              <a:ext uri="{FF2B5EF4-FFF2-40B4-BE49-F238E27FC236}">
-                <a16:creationId xmlns:a16="http://schemas.microsoft.com/office/drawing/2014/main" id="{7A663105-4B92-4F24-9DF6-58BB116E29FA}"/>
+          <p:cNvPr id="2" name="Title 1">
+            <a:extLst>
+              <a:ext uri="{FF2B5EF4-FFF2-40B4-BE49-F238E27FC236}">
+                <a16:creationId xmlns:a16="http://schemas.microsoft.com/office/drawing/2014/main" id="{B35ED38B-2505-420A-A14A-D41E71EDBA33}"/>
               </a:ext>
             </a:extLst>
           </p:cNvPr>
@@ -20975,8 +21599,8 @@
         </p:nvSpPr>
         <p:spPr bwMode="black">
           <a:xfrm>
-            <a:off x="2681686" y="184488"/>
-            <a:ext cx="5085650" cy="720000"/>
+            <a:off x="6957824" y="902486"/>
+            <a:ext cx="3530583" cy="1252433"/>
           </a:xfrm>
         </p:spPr>
         <p:txBody>
@@ -20985,17 +21609,17 @@
           <a:p>
             <a:r>
               <a:rPr lang="en-US" b="1" dirty="0"/>
-              <a:t>Methodology</a:t>
-            </a:r>
-          </a:p>
-        </p:txBody>
-      </p:sp>
-      <p:sp>
-        <p:nvSpPr>
-          <p:cNvPr id="4" name="Subtitle 3">
-            <a:extLst>
-              <a:ext uri="{FF2B5EF4-FFF2-40B4-BE49-F238E27FC236}">
-                <a16:creationId xmlns:a16="http://schemas.microsoft.com/office/drawing/2014/main" id="{8E41F722-BA6E-4DCA-864E-876ECDFB5336}"/>
+              <a:t>  The Challenge</a:t>
+            </a:r>
+          </a:p>
+        </p:txBody>
+      </p:sp>
+      <p:sp>
+        <p:nvSpPr>
+          <p:cNvPr id="3" name="Subtitle 2">
+            <a:extLst>
+              <a:ext uri="{FF2B5EF4-FFF2-40B4-BE49-F238E27FC236}">
+                <a16:creationId xmlns:a16="http://schemas.microsoft.com/office/drawing/2014/main" id="{71F217F2-8C36-4584-BD5D-0B00606DF9A2}"/>
               </a:ext>
             </a:extLst>
           </p:cNvPr>
@@ -21008,230 +21632,49 @@
         </p:nvSpPr>
         <p:spPr bwMode="black">
           <a:xfrm>
-            <a:off x="492369" y="544487"/>
-            <a:ext cx="11408899" cy="5995677"/>
+            <a:off x="6473312" y="2384075"/>
+            <a:ext cx="5085650" cy="2363129"/>
           </a:xfrm>
         </p:spPr>
         <p:txBody>
           <a:bodyPr/>
           <a:lstStyle/>
           <a:p>
-            <a:pPr algn="l"/>
-            <a:endParaRPr lang="en-US" sz="1800" b="1" dirty="0">
-              <a:solidFill>
-                <a:srgbClr val="FFC000"/>
-              </a:solidFill>
-            </a:endParaRPr>
-          </a:p>
-          <a:p>
-            <a:pPr algn="l"/>
-            <a:r>
-              <a:rPr lang="en-US" sz="1800" b="1" dirty="0">
-                <a:solidFill>
-                  <a:srgbClr val="FFC000"/>
+            <a:pPr algn="ctr"/>
+            <a:r>
+              <a:rPr lang="en-US" dirty="0">
+                <a:solidFill>
+                  <a:schemeClr val="accent1">
+                    <a:lumMod val="60000"/>
+                    <a:lumOff val="40000"/>
+                  </a:schemeClr>
                 </a:solidFill>
               </a:rPr>
-              <a:t>ROSEMED Methodology</a:t>
-            </a:r>
-            <a:r>
-              <a:rPr lang="en-US" sz="1800" dirty="0">
-                <a:solidFill>
-                  <a:srgbClr val="FFC000"/>
+              <a:t>Build an algorithm to identify whether a patient is suffering from pneumonia or not, by looking at chest X-ray images.</a:t>
+            </a:r>
+          </a:p>
+          <a:p>
+            <a:pPr algn="ctr"/>
+            <a:r>
+              <a:rPr lang="en-US" dirty="0">
+                <a:solidFill>
+                  <a:schemeClr val="accent1">
+                    <a:lumMod val="60000"/>
+                    <a:lumOff val="40000"/>
+                  </a:schemeClr>
                 </a:solidFill>
               </a:rPr>
-              <a:t> - This is the one of the most straightforward of the Data Science processes.</a:t>
-            </a:r>
-          </a:p>
-          <a:p>
-            <a:pPr algn="l"/>
-            <a:br>
-              <a:rPr lang="en-US" sz="1800" dirty="0">
-                <a:solidFill>
-                  <a:srgbClr val="FFC000"/>
-                </a:solidFill>
-              </a:rPr>
-            </a:br>
-            <a:r>
-              <a:rPr lang="en-US" sz="1800" b="1" dirty="0">
-                <a:solidFill>
-                  <a:srgbClr val="FFC000"/>
-                </a:solidFill>
-              </a:rPr>
-              <a:t>Research</a:t>
-            </a:r>
-            <a:r>
-              <a:rPr lang="en-US" sz="1800" dirty="0">
-                <a:solidFill>
-                  <a:srgbClr val="FFC000"/>
-                </a:solidFill>
-              </a:rPr>
-              <a:t> - Find out about various models and see which model works best for our data.</a:t>
-            </a:r>
-          </a:p>
-          <a:p>
-            <a:pPr algn="l"/>
-            <a:br>
-              <a:rPr lang="en-US" sz="1800" dirty="0">
-                <a:solidFill>
-                  <a:srgbClr val="FFC000"/>
-                </a:solidFill>
-              </a:rPr>
-            </a:br>
-            <a:r>
-              <a:rPr lang="en-US" sz="1800" b="1" dirty="0">
-                <a:solidFill>
-                  <a:srgbClr val="FFC000"/>
-                </a:solidFill>
-              </a:rPr>
-              <a:t>Obtain</a:t>
-            </a:r>
-            <a:r>
-              <a:rPr lang="en-US" sz="1800" dirty="0">
-                <a:solidFill>
-                  <a:srgbClr val="FFC000"/>
-                </a:solidFill>
-              </a:rPr>
-              <a:t> - Understanding stakeholder requirements, gathering information on the problem, and finally, sourcing data that we think will be necessary for solving this problem.</a:t>
-            </a:r>
-          </a:p>
-          <a:p>
-            <a:pPr algn="l"/>
-            <a:br>
-              <a:rPr lang="en-US" sz="1800" dirty="0">
-                <a:solidFill>
-                  <a:srgbClr val="FFC000"/>
-                </a:solidFill>
-              </a:rPr>
-            </a:br>
-            <a:r>
-              <a:rPr lang="en-US" sz="1800" b="1" dirty="0">
-                <a:solidFill>
-                  <a:srgbClr val="FFC000"/>
-                </a:solidFill>
-              </a:rPr>
-              <a:t>Scrub</a:t>
-            </a:r>
-            <a:r>
-              <a:rPr lang="en-US" sz="1800" dirty="0">
-                <a:solidFill>
-                  <a:srgbClr val="FFC000"/>
-                </a:solidFill>
-              </a:rPr>
-              <a:t> - Focus on preprocessing our data. Important steps such as identifying and removing null values, dealing with outliers, normalizing data, and feature engineering/feature selection are handled around this stage.</a:t>
-            </a:r>
-          </a:p>
-          <a:p>
-            <a:pPr algn="l"/>
-            <a:br>
-              <a:rPr lang="en-US" sz="1800" dirty="0">
-                <a:solidFill>
-                  <a:srgbClr val="FFC000"/>
-                </a:solidFill>
-              </a:rPr>
-            </a:br>
-            <a:r>
-              <a:rPr lang="en-US" sz="1800" b="1" dirty="0">
-                <a:solidFill>
-                  <a:srgbClr val="FFC000"/>
-                </a:solidFill>
-              </a:rPr>
-              <a:t>Explore</a:t>
-            </a:r>
-            <a:r>
-              <a:rPr lang="en-US" sz="1800" dirty="0">
-                <a:solidFill>
-                  <a:srgbClr val="FFC000"/>
-                </a:solidFill>
-              </a:rPr>
-              <a:t> - We create visualizations to really get a feel of the dataset. We focus on things such as understanding the distribution of different columns, checking for multicollinearity, and other tasks like that.</a:t>
-            </a:r>
-          </a:p>
-          <a:p>
-            <a:pPr algn="l"/>
-            <a:br>
-              <a:rPr lang="en-US" sz="1800" dirty="0">
-                <a:solidFill>
-                  <a:srgbClr val="FFC000"/>
-                </a:solidFill>
-              </a:rPr>
-            </a:br>
-            <a:r>
-              <a:rPr lang="en-US" sz="1800" b="1" dirty="0">
-                <a:solidFill>
-                  <a:srgbClr val="FFC000"/>
-                </a:solidFill>
-              </a:rPr>
-              <a:t>Model</a:t>
-            </a:r>
-            <a:r>
-              <a:rPr lang="en-US" sz="1800" dirty="0">
-                <a:solidFill>
-                  <a:srgbClr val="FFC000"/>
-                </a:solidFill>
-              </a:rPr>
-              <a:t> - It consists of building and tuning models using all the tools we have in our data science toolbox. </a:t>
-            </a:r>
-          </a:p>
-          <a:p>
-            <a:pPr algn="l"/>
-            <a:br>
-              <a:rPr lang="en-US" sz="1800" dirty="0">
-                <a:solidFill>
-                  <a:srgbClr val="FFC000"/>
-                </a:solidFill>
-              </a:rPr>
-            </a:br>
-            <a:r>
-              <a:rPr lang="en-US" sz="1800" b="1" dirty="0">
-                <a:solidFill>
-                  <a:srgbClr val="FFC000"/>
-                </a:solidFill>
-              </a:rPr>
-              <a:t>Evaluate</a:t>
-            </a:r>
-            <a:r>
-              <a:rPr lang="en-US" sz="1800" dirty="0">
-                <a:solidFill>
-                  <a:srgbClr val="FFC000"/>
-                </a:solidFill>
-              </a:rPr>
-              <a:t> - Interpret the results of models and communicate results to stakeholders.</a:t>
-            </a:r>
-          </a:p>
-          <a:p>
-            <a:pPr algn="l"/>
-            <a:br>
-              <a:rPr lang="en-US" sz="1800" dirty="0">
-                <a:solidFill>
-                  <a:srgbClr val="FFC000"/>
-                </a:solidFill>
-              </a:rPr>
-            </a:br>
-            <a:r>
-              <a:rPr lang="en-US" sz="1800" b="1" dirty="0">
-                <a:solidFill>
-                  <a:srgbClr val="FFC000"/>
-                </a:solidFill>
-              </a:rPr>
-              <a:t>Deploy</a:t>
-            </a:r>
-            <a:r>
-              <a:rPr lang="en-US" sz="1800" dirty="0">
-                <a:solidFill>
-                  <a:srgbClr val="FFC000"/>
-                </a:solidFill>
-              </a:rPr>
-              <a:t> - Deploying the Model.</a:t>
-            </a:r>
-          </a:p>
-        </p:txBody>
-      </p:sp>
-      <p:sp>
-        <p:nvSpPr>
-          <p:cNvPr id="5" name="Slide Number Placeholder 4">
-            <a:extLst>
-              <a:ext uri="{FF2B5EF4-FFF2-40B4-BE49-F238E27FC236}">
-                <a16:creationId xmlns:a16="http://schemas.microsoft.com/office/drawing/2014/main" id="{185B41C8-4B55-458F-878B-550AD24B15E9}"/>
+              <a:t> The algorithm must be extremely accurate because lives of people is at stake.</a:t>
+            </a:r>
+          </a:p>
+        </p:txBody>
+      </p:sp>
+      <p:sp>
+        <p:nvSpPr>
+          <p:cNvPr id="23" name="Slide Number Placeholder 22">
+            <a:extLst>
+              <a:ext uri="{FF2B5EF4-FFF2-40B4-BE49-F238E27FC236}">
+                <a16:creationId xmlns:a16="http://schemas.microsoft.com/office/drawing/2014/main" id="{4D5E33D6-D847-4F4C-BA8B-75CB853FAB76}"/>
               </a:ext>
             </a:extLst>
           </p:cNvPr>
@@ -21244,7 +21687,7 @@
         </p:nvSpPr>
         <p:spPr>
           <a:xfrm>
-            <a:off x="10526518" y="6275834"/>
+            <a:off x="11077565" y="6371957"/>
             <a:ext cx="962795" cy="264330"/>
           </a:xfrm>
           <a:ln>
@@ -21283,7 +21726,7 @@
     </p:spTree>
     <p:extLst>
       <p:ext uri="{BB962C8B-B14F-4D97-AF65-F5344CB8AC3E}">
-        <p14:creationId xmlns:p14="http://schemas.microsoft.com/office/powerpoint/2010/main" val="2122728967"/>
+        <p14:creationId xmlns:p14="http://schemas.microsoft.com/office/powerpoint/2010/main" val="909226357"/>
       </p:ext>
     </p:extLst>
   </p:cSld>
@@ -21310,117 +21753,363 @@
           <a:chExt cx="0" cy="0"/>
         </a:xfrm>
       </p:grpSpPr>
-      <p:pic>
-        <p:nvPicPr>
-          <p:cNvPr id="13" name="Picture 2" descr="A screenshot of a cell phone&#10;&#10;Description automatically generated">
-            <a:extLst>
-              <a:ext uri="{FF2B5EF4-FFF2-40B4-BE49-F238E27FC236}">
-                <a16:creationId xmlns:a16="http://schemas.microsoft.com/office/drawing/2014/main" id="{346E2A40-5E33-4A55-ADA2-014365CACD35}"/>
-              </a:ext>
-            </a:extLst>
-          </p:cNvPr>
-          <p:cNvPicPr>
-            <a:picLocks noChangeAspect="1" noChangeArrowheads="1"/>
-          </p:cNvPicPr>
+      <p:sp>
+        <p:nvSpPr>
+          <p:cNvPr id="9" name="Rectangle 8">
+            <a:extLst>
+              <a:ext uri="{FF2B5EF4-FFF2-40B4-BE49-F238E27FC236}">
+                <a16:creationId xmlns:a16="http://schemas.microsoft.com/office/drawing/2014/main" id="{670550D9-B72F-46D0-B3A1-179DADF002AC}"/>
+              </a:ext>
+              <a:ext uri="{C183D7F6-B498-43B3-948B-1728B52AA6E4}">
+                <adec:decorative xmlns:adec="http://schemas.microsoft.com/office/drawing/2017/decorative" val="1"/>
+              </a:ext>
+            </a:extLst>
+          </p:cNvPr>
+          <p:cNvSpPr/>
           <p:nvPr/>
-        </p:nvPicPr>
-        <p:blipFill>
-          <a:blip r:embed="rId2">
-            <a:extLst>
-              <a:ext uri="{28A0092B-C50C-407E-A947-70E740481C1C}">
-                <a14:useLocalDpi xmlns:a14="http://schemas.microsoft.com/office/drawing/2010/main" val="0"/>
-              </a:ext>
-            </a:extLst>
-          </a:blip>
-          <a:stretch>
-            <a:fillRect/>
-          </a:stretch>
-        </p:blipFill>
-        <p:spPr bwMode="auto">
-          <a:xfrm>
-            <a:off x="260029" y="1586224"/>
-            <a:ext cx="11219207" cy="3137085"/>
+        </p:nvSpPr>
+        <p:spPr bwMode="invGray">
+          <a:xfrm rot="5400000">
+            <a:off x="2741314" y="-2528060"/>
+            <a:ext cx="6687139" cy="11914120"/>
           </a:xfrm>
           <a:prstGeom prst="rect">
             <a:avLst/>
           </a:prstGeom>
           <a:solidFill>
-            <a:srgbClr val="FFFFFF"/>
+            <a:schemeClr val="tx1">
+              <a:alpha val="70000"/>
+            </a:schemeClr>
           </a:solidFill>
-        </p:spPr>
-      </p:pic>
-      <p:sp>
-        <p:nvSpPr>
-          <p:cNvPr id="18" name="Title 2">
-            <a:extLst>
-              <a:ext uri="{FF2B5EF4-FFF2-40B4-BE49-F238E27FC236}">
-                <a16:creationId xmlns:a16="http://schemas.microsoft.com/office/drawing/2014/main" id="{379354DF-9011-4DAE-9484-A9B7A3B66BEC}"/>
-              </a:ext>
-            </a:extLst>
-          </p:cNvPr>
-          <p:cNvSpPr>
-            <a:spLocks noGrp="1"/>
-          </p:cNvSpPr>
-          <p:nvPr>
-            <p:ph type="ctrTitle"/>
-          </p:nvPr>
-        </p:nvSpPr>
-        <p:spPr>
-          <a:xfrm>
-            <a:off x="2888402" y="295421"/>
-            <a:ext cx="5990599" cy="872197"/>
-          </a:xfrm>
-        </p:spPr>
-        <p:txBody>
-          <a:bodyPr/>
-          <a:lstStyle/>
-          <a:p>
-            <a:pPr algn="ctr"/>
-            <a:r>
-              <a:rPr lang="en-US" b="1" dirty="0"/>
-              <a:t>Our Data</a:t>
-            </a:r>
-          </a:p>
-        </p:txBody>
-      </p:sp>
-      <p:sp>
-        <p:nvSpPr>
-          <p:cNvPr id="3" name="Slide Number Placeholder 2">
-            <a:extLst>
-              <a:ext uri="{FF2B5EF4-FFF2-40B4-BE49-F238E27FC236}">
-                <a16:creationId xmlns:a16="http://schemas.microsoft.com/office/drawing/2014/main" id="{4C3996F5-ECB2-47E1-8BFD-CC4281CEFD13}"/>
-              </a:ext>
-            </a:extLst>
-          </p:cNvPr>
-          <p:cNvSpPr>
-            <a:spLocks noGrp="1"/>
-          </p:cNvSpPr>
-          <p:nvPr>
-            <p:ph type="sldNum" sz="quarter" idx="12"/>
-          </p:nvPr>
-        </p:nvSpPr>
-        <p:spPr>
-          <a:xfrm>
-            <a:off x="11091633" y="6456363"/>
-            <a:ext cx="962795" cy="264330"/>
-          </a:xfrm>
           <a:ln>
             <a:noFill/>
           </a:ln>
         </p:spPr>
-        <p:txBody>
-          <a:bodyPr anchor="ctr">
-            <a:normAutofit/>
-          </a:bodyPr>
+        <p:style>
+          <a:lnRef idx="2">
+            <a:schemeClr val="accent1">
+              <a:shade val="50000"/>
+            </a:schemeClr>
+          </a:lnRef>
+          <a:fillRef idx="1">
+            <a:schemeClr val="accent1"/>
+          </a:fillRef>
+          <a:effectRef idx="0">
+            <a:schemeClr val="accent1"/>
+          </a:effectRef>
+          <a:fontRef idx="minor">
+            <a:schemeClr val="lt1"/>
+          </a:fontRef>
+        </p:style>
+        <p:txBody>
+          <a:bodyPr rtlCol="0" anchor="ctr"/>
           <a:lstStyle/>
           <a:p>
-            <a:pPr>
-              <a:spcAft>
-                <a:spcPts val="600"/>
-              </a:spcAft>
-            </a:pPr>
-            <a:r>
-              <a:rPr lang="en-US" noProof="0" dirty="0">
+            <a:pPr algn="ctr"/>
+            <a:endParaRPr lang="en-US" dirty="0"/>
+          </a:p>
+        </p:txBody>
+      </p:sp>
+      <p:sp>
+        <p:nvSpPr>
+          <p:cNvPr id="3" name="Title 2">
+            <a:extLst>
+              <a:ext uri="{FF2B5EF4-FFF2-40B4-BE49-F238E27FC236}">
+                <a16:creationId xmlns:a16="http://schemas.microsoft.com/office/drawing/2014/main" id="{7A663105-4B92-4F24-9DF6-58BB116E29FA}"/>
+              </a:ext>
+            </a:extLst>
+          </p:cNvPr>
+          <p:cNvSpPr>
+            <a:spLocks noGrp="1"/>
+          </p:cNvSpPr>
+          <p:nvPr>
+            <p:ph type="ctrTitle"/>
+          </p:nvPr>
+        </p:nvSpPr>
+        <p:spPr bwMode="black">
+          <a:xfrm>
+            <a:off x="2681686" y="184488"/>
+            <a:ext cx="5085650" cy="720000"/>
+          </a:xfrm>
+        </p:spPr>
+        <p:txBody>
+          <a:bodyPr/>
+          <a:lstStyle/>
+          <a:p>
+            <a:r>
+              <a:rPr lang="en-US" b="1" dirty="0"/>
+              <a:t>Methodology</a:t>
+            </a:r>
+          </a:p>
+        </p:txBody>
+      </p:sp>
+      <p:sp>
+        <p:nvSpPr>
+          <p:cNvPr id="4" name="Subtitle 3">
+            <a:extLst>
+              <a:ext uri="{FF2B5EF4-FFF2-40B4-BE49-F238E27FC236}">
+                <a16:creationId xmlns:a16="http://schemas.microsoft.com/office/drawing/2014/main" id="{8E41F722-BA6E-4DCA-864E-876ECDFB5336}"/>
+              </a:ext>
+            </a:extLst>
+          </p:cNvPr>
+          <p:cNvSpPr>
+            <a:spLocks noGrp="1"/>
+          </p:cNvSpPr>
+          <p:nvPr>
+            <p:ph type="subTitle" idx="1"/>
+          </p:nvPr>
+        </p:nvSpPr>
+        <p:spPr bwMode="black">
+          <a:xfrm>
+            <a:off x="492369" y="544487"/>
+            <a:ext cx="11408899" cy="5995677"/>
+          </a:xfrm>
+        </p:spPr>
+        <p:txBody>
+          <a:bodyPr/>
+          <a:lstStyle/>
+          <a:p>
+            <a:pPr algn="l"/>
+            <a:endParaRPr lang="en-US" sz="1800" b="1" dirty="0">
+              <a:solidFill>
+                <a:srgbClr val="FFC000"/>
+              </a:solidFill>
+            </a:endParaRPr>
+          </a:p>
+          <a:p>
+            <a:pPr algn="l"/>
+            <a:r>
+              <a:rPr lang="en-US" sz="1800" b="1" dirty="0">
+                <a:solidFill>
+                  <a:srgbClr val="FFC000"/>
+                </a:solidFill>
+              </a:rPr>
+              <a:t>ROSEMED Methodology</a:t>
+            </a:r>
+            <a:r>
+              <a:rPr lang="en-US" sz="1800" dirty="0">
+                <a:solidFill>
+                  <a:srgbClr val="FFC000"/>
+                </a:solidFill>
+              </a:rPr>
+              <a:t> - This is the one of the most straightforward of the Data Science processes.</a:t>
+            </a:r>
+          </a:p>
+          <a:p>
+            <a:pPr algn="l"/>
+            <a:br>
+              <a:rPr lang="en-US" sz="1800" dirty="0">
+                <a:solidFill>
+                  <a:srgbClr val="FFC000"/>
+                </a:solidFill>
+              </a:rPr>
+            </a:br>
+            <a:r>
+              <a:rPr lang="en-US" sz="1800" b="1" dirty="0">
+                <a:solidFill>
+                  <a:srgbClr val="FFC000"/>
+                </a:solidFill>
+              </a:rPr>
+              <a:t>Research</a:t>
+            </a:r>
+            <a:r>
+              <a:rPr lang="en-US" sz="1800" dirty="0">
+                <a:solidFill>
+                  <a:srgbClr val="FFC000"/>
+                </a:solidFill>
+              </a:rPr>
+              <a:t> - Find out about various models and see which model works best for our data.</a:t>
+            </a:r>
+          </a:p>
+          <a:p>
+            <a:pPr algn="l"/>
+            <a:br>
+              <a:rPr lang="en-US" sz="1800" dirty="0">
+                <a:solidFill>
+                  <a:srgbClr val="FFC000"/>
+                </a:solidFill>
+              </a:rPr>
+            </a:br>
+            <a:r>
+              <a:rPr lang="en-US" sz="1800" b="1" dirty="0">
+                <a:solidFill>
+                  <a:srgbClr val="FFC000"/>
+                </a:solidFill>
+              </a:rPr>
+              <a:t>Obtain</a:t>
+            </a:r>
+            <a:r>
+              <a:rPr lang="en-US" sz="1800" dirty="0">
+                <a:solidFill>
+                  <a:srgbClr val="FFC000"/>
+                </a:solidFill>
+              </a:rPr>
+              <a:t> - Understanding stakeholder requirements, gathering information on the problem, and finally, sourcing data that we think will be necessary for solving this problem.</a:t>
+            </a:r>
+          </a:p>
+          <a:p>
+            <a:pPr algn="l"/>
+            <a:br>
+              <a:rPr lang="en-US" sz="1800" dirty="0">
+                <a:solidFill>
+                  <a:srgbClr val="FFC000"/>
+                </a:solidFill>
+              </a:rPr>
+            </a:br>
+            <a:r>
+              <a:rPr lang="en-US" sz="1800" b="1" dirty="0">
+                <a:solidFill>
+                  <a:srgbClr val="FFC000"/>
+                </a:solidFill>
+              </a:rPr>
+              <a:t>Scrub</a:t>
+            </a:r>
+            <a:r>
+              <a:rPr lang="en-US" sz="1800" dirty="0">
+                <a:solidFill>
+                  <a:srgbClr val="FFC000"/>
+                </a:solidFill>
+              </a:rPr>
+              <a:t> - Focus on preprocessing our data. Important steps such as identifying and removing null values, dealing with outliers, normalizing data, and feature engineering/feature selection are handled around this stage.</a:t>
+            </a:r>
+          </a:p>
+          <a:p>
+            <a:pPr algn="l"/>
+            <a:br>
+              <a:rPr lang="en-US" sz="1800" dirty="0">
+                <a:solidFill>
+                  <a:srgbClr val="FFC000"/>
+                </a:solidFill>
+              </a:rPr>
+            </a:br>
+            <a:r>
+              <a:rPr lang="en-US" sz="1800" b="1" dirty="0">
+                <a:solidFill>
+                  <a:srgbClr val="FFC000"/>
+                </a:solidFill>
+              </a:rPr>
+              <a:t>Explore</a:t>
+            </a:r>
+            <a:r>
+              <a:rPr lang="en-US" sz="1800" dirty="0">
+                <a:solidFill>
+                  <a:srgbClr val="FFC000"/>
+                </a:solidFill>
+              </a:rPr>
+              <a:t> - We create visualizations to really get a feel of the dataset. We focus on things such as understanding the distribution of different columns, checking for multicollinearity, and other tasks like that.</a:t>
+            </a:r>
+          </a:p>
+          <a:p>
+            <a:pPr algn="l"/>
+            <a:br>
+              <a:rPr lang="en-US" sz="1800" dirty="0">
+                <a:solidFill>
+                  <a:srgbClr val="FFC000"/>
+                </a:solidFill>
+              </a:rPr>
+            </a:br>
+            <a:r>
+              <a:rPr lang="en-US" sz="1800" b="1" dirty="0">
+                <a:solidFill>
+                  <a:srgbClr val="FFC000"/>
+                </a:solidFill>
+              </a:rPr>
+              <a:t>Model</a:t>
+            </a:r>
+            <a:r>
+              <a:rPr lang="en-US" sz="1800" dirty="0">
+                <a:solidFill>
+                  <a:srgbClr val="FFC000"/>
+                </a:solidFill>
+              </a:rPr>
+              <a:t> - It consists of building and tuning models using all the tools we have in our data science toolbox. </a:t>
+            </a:r>
+          </a:p>
+          <a:p>
+            <a:pPr algn="l"/>
+            <a:br>
+              <a:rPr lang="en-US" sz="1800" dirty="0">
+                <a:solidFill>
+                  <a:srgbClr val="FFC000"/>
+                </a:solidFill>
+              </a:rPr>
+            </a:br>
+            <a:r>
+              <a:rPr lang="en-US" sz="1800" b="1" dirty="0">
+                <a:solidFill>
+                  <a:srgbClr val="FFC000"/>
+                </a:solidFill>
+              </a:rPr>
+              <a:t>Evaluate</a:t>
+            </a:r>
+            <a:r>
+              <a:rPr lang="en-US" sz="1800" dirty="0">
+                <a:solidFill>
+                  <a:srgbClr val="FFC000"/>
+                </a:solidFill>
+              </a:rPr>
+              <a:t> - Interpret the results of models and communicate results to stakeholders.</a:t>
+            </a:r>
+          </a:p>
+          <a:p>
+            <a:pPr algn="l"/>
+            <a:br>
+              <a:rPr lang="en-US" sz="1800" dirty="0">
+                <a:solidFill>
+                  <a:srgbClr val="FFC000"/>
+                </a:solidFill>
+              </a:rPr>
+            </a:br>
+            <a:r>
+              <a:rPr lang="en-US" sz="1800" b="1" dirty="0">
+                <a:solidFill>
+                  <a:srgbClr val="FFC000"/>
+                </a:solidFill>
+              </a:rPr>
+              <a:t>Deploy</a:t>
+            </a:r>
+            <a:r>
+              <a:rPr lang="en-US" sz="1800" dirty="0">
+                <a:solidFill>
+                  <a:srgbClr val="FFC000"/>
+                </a:solidFill>
+              </a:rPr>
+              <a:t> - Deploying the Model.</a:t>
+            </a:r>
+          </a:p>
+        </p:txBody>
+      </p:sp>
+      <p:sp>
+        <p:nvSpPr>
+          <p:cNvPr id="5" name="Slide Number Placeholder 4">
+            <a:extLst>
+              <a:ext uri="{FF2B5EF4-FFF2-40B4-BE49-F238E27FC236}">
+                <a16:creationId xmlns:a16="http://schemas.microsoft.com/office/drawing/2014/main" id="{185B41C8-4B55-458F-878B-550AD24B15E9}"/>
+              </a:ext>
+            </a:extLst>
+          </p:cNvPr>
+          <p:cNvSpPr>
+            <a:spLocks noGrp="1"/>
+          </p:cNvSpPr>
+          <p:nvPr>
+            <p:ph type="sldNum" sz="quarter" idx="12"/>
+          </p:nvPr>
+        </p:nvSpPr>
+        <p:spPr>
+          <a:xfrm>
+            <a:off x="10526518" y="6275834"/>
+            <a:ext cx="962795" cy="264330"/>
+          </a:xfrm>
+          <a:ln>
+            <a:noFill/>
+          </a:ln>
+        </p:spPr>
+        <p:txBody>
+          <a:bodyPr/>
+          <a:lstStyle/>
+          <a:p>
+            <a:r>
+              <a:rPr lang="en-US" dirty="0">
                 <a:solidFill>
                   <a:schemeClr val="bg1"/>
                 </a:solidFill>
@@ -21428,19 +22117,15 @@
               <a:t>page </a:t>
             </a:r>
             <a:fld id="{19B51A1E-902D-48AF-9020-955120F399B6}" type="slidenum">
-              <a:rPr lang="en-US" b="1" i="1" noProof="0" smtClean="0">
+              <a:rPr lang="en-US" smtClean="0">
                 <a:solidFill>
                   <a:schemeClr val="bg1"/>
                 </a:solidFill>
               </a:rPr>
-              <a:pPr>
-                <a:spcAft>
-                  <a:spcPts val="600"/>
-                </a:spcAft>
-              </a:pPr>
+              <a:pPr/>
               <a:t>5</a:t>
             </a:fld>
-            <a:endParaRPr lang="en-US" b="1" i="1" noProof="0" dirty="0">
+            <a:endParaRPr lang="en-US" dirty="0">
               <a:solidFill>
                 <a:schemeClr val="bg1"/>
               </a:solidFill>
@@ -21448,69 +22133,10 @@
           </a:p>
         </p:txBody>
       </p:sp>
-      <p:sp>
-        <p:nvSpPr>
-          <p:cNvPr id="15" name="TextBox 14">
-            <a:extLst>
-              <a:ext uri="{FF2B5EF4-FFF2-40B4-BE49-F238E27FC236}">
-                <a16:creationId xmlns:a16="http://schemas.microsoft.com/office/drawing/2014/main" id="{52068440-4BB7-4B3A-B704-2DE2FEDE7BBB}"/>
-              </a:ext>
-            </a:extLst>
-          </p:cNvPr>
-          <p:cNvSpPr txBox="1"/>
-          <p:nvPr/>
-        </p:nvSpPr>
-        <p:spPr>
-          <a:xfrm>
-            <a:off x="633046" y="4951828"/>
-            <a:ext cx="7371471" cy="923330"/>
-          </a:xfrm>
-          <a:prstGeom prst="rect">
-            <a:avLst/>
-          </a:prstGeom>
-          <a:noFill/>
-        </p:spPr>
-        <p:txBody>
-          <a:bodyPr wrap="square" rtlCol="0">
-            <a:spAutoFit/>
-          </a:bodyPr>
-          <a:lstStyle/>
-          <a:p>
-            <a:r>
-              <a:rPr lang="en-US" b="1" dirty="0">
-                <a:solidFill>
-                  <a:srgbClr val="FFFF00"/>
-                </a:solidFill>
-              </a:rPr>
-              <a:t>In the Train Set:  Normal Images: 1341, Pneumonia Images: 3875</a:t>
-            </a:r>
-          </a:p>
-          <a:p>
-            <a:r>
-              <a:rPr lang="en-US" b="1" dirty="0">
-                <a:solidFill>
-                  <a:srgbClr val="FFFF00"/>
-                </a:solidFill>
-              </a:rPr>
-              <a:t>In the Test Set:  Normal Images: 234, Pneumonia Images: 390</a:t>
-            </a:r>
-          </a:p>
-          <a:p>
-            <a:r>
-              <a:rPr lang="en-US" b="1" dirty="0">
-                <a:solidFill>
-                  <a:srgbClr val="FFFF00"/>
-                </a:solidFill>
-              </a:rPr>
-              <a:t>In the Val Set:  Normal Images: 8, Pneumonia Images: 8</a:t>
-            </a:r>
-          </a:p>
-        </p:txBody>
-      </p:sp>
     </p:spTree>
     <p:extLst>
       <p:ext uri="{BB962C8B-B14F-4D97-AF65-F5344CB8AC3E}">
-        <p14:creationId xmlns:p14="http://schemas.microsoft.com/office/powerpoint/2010/main" val="2128953142"/>
+        <p14:creationId xmlns:p14="http://schemas.microsoft.com/office/powerpoint/2010/main" val="2122728967"/>
       </p:ext>
     </p:extLst>
   </p:cSld>
@@ -21537,6 +22163,233 @@
           <a:chExt cx="0" cy="0"/>
         </a:xfrm>
       </p:grpSpPr>
+      <p:pic>
+        <p:nvPicPr>
+          <p:cNvPr id="13" name="Picture 2" descr="A screenshot of a cell phone&#10;&#10;Description automatically generated">
+            <a:extLst>
+              <a:ext uri="{FF2B5EF4-FFF2-40B4-BE49-F238E27FC236}">
+                <a16:creationId xmlns:a16="http://schemas.microsoft.com/office/drawing/2014/main" id="{346E2A40-5E33-4A55-ADA2-014365CACD35}"/>
+              </a:ext>
+            </a:extLst>
+          </p:cNvPr>
+          <p:cNvPicPr>
+            <a:picLocks noChangeAspect="1" noChangeArrowheads="1"/>
+          </p:cNvPicPr>
+          <p:nvPr/>
+        </p:nvPicPr>
+        <p:blipFill>
+          <a:blip r:embed="rId2">
+            <a:extLst>
+              <a:ext uri="{28A0092B-C50C-407E-A947-70E740481C1C}">
+                <a14:useLocalDpi xmlns:a14="http://schemas.microsoft.com/office/drawing/2010/main" val="0"/>
+              </a:ext>
+            </a:extLst>
+          </a:blip>
+          <a:stretch>
+            <a:fillRect/>
+          </a:stretch>
+        </p:blipFill>
+        <p:spPr bwMode="auto">
+          <a:xfrm>
+            <a:off x="260029" y="1586224"/>
+            <a:ext cx="11219207" cy="3137085"/>
+          </a:xfrm>
+          <a:prstGeom prst="rect">
+            <a:avLst/>
+          </a:prstGeom>
+          <a:solidFill>
+            <a:srgbClr val="FFFFFF"/>
+          </a:solidFill>
+        </p:spPr>
+      </p:pic>
+      <p:sp>
+        <p:nvSpPr>
+          <p:cNvPr id="18" name="Title 2">
+            <a:extLst>
+              <a:ext uri="{FF2B5EF4-FFF2-40B4-BE49-F238E27FC236}">
+                <a16:creationId xmlns:a16="http://schemas.microsoft.com/office/drawing/2014/main" id="{379354DF-9011-4DAE-9484-A9B7A3B66BEC}"/>
+              </a:ext>
+            </a:extLst>
+          </p:cNvPr>
+          <p:cNvSpPr>
+            <a:spLocks noGrp="1"/>
+          </p:cNvSpPr>
+          <p:nvPr>
+            <p:ph type="ctrTitle"/>
+          </p:nvPr>
+        </p:nvSpPr>
+        <p:spPr>
+          <a:xfrm>
+            <a:off x="2888402" y="295421"/>
+            <a:ext cx="5990599" cy="872197"/>
+          </a:xfrm>
+        </p:spPr>
+        <p:txBody>
+          <a:bodyPr/>
+          <a:lstStyle/>
+          <a:p>
+            <a:pPr algn="ctr"/>
+            <a:r>
+              <a:rPr lang="en-US" b="1" dirty="0"/>
+              <a:t>Our Data</a:t>
+            </a:r>
+          </a:p>
+        </p:txBody>
+      </p:sp>
+      <p:sp>
+        <p:nvSpPr>
+          <p:cNvPr id="3" name="Slide Number Placeholder 2">
+            <a:extLst>
+              <a:ext uri="{FF2B5EF4-FFF2-40B4-BE49-F238E27FC236}">
+                <a16:creationId xmlns:a16="http://schemas.microsoft.com/office/drawing/2014/main" id="{4C3996F5-ECB2-47E1-8BFD-CC4281CEFD13}"/>
+              </a:ext>
+            </a:extLst>
+          </p:cNvPr>
+          <p:cNvSpPr>
+            <a:spLocks noGrp="1"/>
+          </p:cNvSpPr>
+          <p:nvPr>
+            <p:ph type="sldNum" sz="quarter" idx="12"/>
+          </p:nvPr>
+        </p:nvSpPr>
+        <p:spPr>
+          <a:xfrm>
+            <a:off x="11091633" y="6456363"/>
+            <a:ext cx="962795" cy="264330"/>
+          </a:xfrm>
+          <a:ln>
+            <a:noFill/>
+          </a:ln>
+        </p:spPr>
+        <p:txBody>
+          <a:bodyPr anchor="ctr">
+            <a:normAutofit/>
+          </a:bodyPr>
+          <a:lstStyle/>
+          <a:p>
+            <a:pPr>
+              <a:spcAft>
+                <a:spcPts val="600"/>
+              </a:spcAft>
+            </a:pPr>
+            <a:r>
+              <a:rPr lang="en-US" noProof="0" dirty="0">
+                <a:solidFill>
+                  <a:schemeClr val="bg1"/>
+                </a:solidFill>
+              </a:rPr>
+              <a:t>page </a:t>
+            </a:r>
+            <a:fld id="{19B51A1E-902D-48AF-9020-955120F399B6}" type="slidenum">
+              <a:rPr lang="en-US" b="1" i="1" noProof="0" smtClean="0">
+                <a:solidFill>
+                  <a:schemeClr val="bg1"/>
+                </a:solidFill>
+              </a:rPr>
+              <a:pPr>
+                <a:spcAft>
+                  <a:spcPts val="600"/>
+                </a:spcAft>
+              </a:pPr>
+              <a:t>6</a:t>
+            </a:fld>
+            <a:endParaRPr lang="en-US" b="1" i="1" noProof="0" dirty="0">
+              <a:solidFill>
+                <a:schemeClr val="bg1"/>
+              </a:solidFill>
+            </a:endParaRPr>
+          </a:p>
+        </p:txBody>
+      </p:sp>
+      <p:sp>
+        <p:nvSpPr>
+          <p:cNvPr id="15" name="TextBox 14">
+            <a:extLst>
+              <a:ext uri="{FF2B5EF4-FFF2-40B4-BE49-F238E27FC236}">
+                <a16:creationId xmlns:a16="http://schemas.microsoft.com/office/drawing/2014/main" id="{52068440-4BB7-4B3A-B704-2DE2FEDE7BBB}"/>
+              </a:ext>
+            </a:extLst>
+          </p:cNvPr>
+          <p:cNvSpPr txBox="1"/>
+          <p:nvPr/>
+        </p:nvSpPr>
+        <p:spPr>
+          <a:xfrm>
+            <a:off x="633046" y="4951828"/>
+            <a:ext cx="7371471" cy="923330"/>
+          </a:xfrm>
+          <a:prstGeom prst="rect">
+            <a:avLst/>
+          </a:prstGeom>
+          <a:noFill/>
+        </p:spPr>
+        <p:txBody>
+          <a:bodyPr wrap="square" rtlCol="0">
+            <a:spAutoFit/>
+          </a:bodyPr>
+          <a:lstStyle/>
+          <a:p>
+            <a:r>
+              <a:rPr lang="en-US" b="1" dirty="0">
+                <a:solidFill>
+                  <a:srgbClr val="FFFF00"/>
+                </a:solidFill>
+              </a:rPr>
+              <a:t>In the Train Set:  Normal Images: 1341, Pneumonia Images: 3875</a:t>
+            </a:r>
+          </a:p>
+          <a:p>
+            <a:r>
+              <a:rPr lang="en-US" b="1" dirty="0">
+                <a:solidFill>
+                  <a:srgbClr val="FFFF00"/>
+                </a:solidFill>
+              </a:rPr>
+              <a:t>In the Test Set:  Normal Images: 234, Pneumonia Images: 390</a:t>
+            </a:r>
+          </a:p>
+          <a:p>
+            <a:r>
+              <a:rPr lang="en-US" b="1" dirty="0">
+                <a:solidFill>
+                  <a:srgbClr val="FFFF00"/>
+                </a:solidFill>
+              </a:rPr>
+              <a:t>In the Val Set:  Normal Images: 8, Pneumonia Images: 8</a:t>
+            </a:r>
+          </a:p>
+        </p:txBody>
+      </p:sp>
+    </p:spTree>
+    <p:extLst>
+      <p:ext uri="{BB962C8B-B14F-4D97-AF65-F5344CB8AC3E}">
+        <p14:creationId xmlns:p14="http://schemas.microsoft.com/office/powerpoint/2010/main" val="2128953142"/>
+      </p:ext>
+    </p:extLst>
+  </p:cSld>
+  <p:clrMapOvr>
+    <a:masterClrMapping/>
+  </p:clrMapOvr>
+</p:sld>
+</file>
+
+<file path=ppt/slides/slide7.xml><?xml version="1.0" encoding="utf-8"?>
+<p:sld xmlns:a="http://schemas.openxmlformats.org/drawingml/2006/main" xmlns:r="http://schemas.openxmlformats.org/officeDocument/2006/relationships" xmlns:p="http://schemas.openxmlformats.org/presentationml/2006/main" showMasterSp="0">
+  <p:cSld>
+    <p:spTree>
+      <p:nvGrpSpPr>
+        <p:cNvPr id="1" name=""/>
+        <p:cNvGrpSpPr/>
+        <p:nvPr/>
+      </p:nvGrpSpPr>
+      <p:grpSpPr>
+        <a:xfrm>
+          <a:off x="0" y="0"/>
+          <a:ext cx="0" cy="0"/>
+          <a:chOff x="0" y="0"/>
+          <a:chExt cx="0" cy="0"/>
+        </a:xfrm>
+      </p:grpSpPr>
       <p:sp>
         <p:nvSpPr>
           <p:cNvPr id="3" name="Title 2">
@@ -21804,7 +22657,7 @@
                 </a:solidFill>
               </a:rPr>
               <a:pPr/>
-              <a:t>6</a:t>
+              <a:t>7</a:t>
             </a:fld>
             <a:endParaRPr lang="en-US" b="1" i="1" noProof="0" dirty="0">
               <a:solidFill>
@@ -22792,7 +23645,7 @@
 </p:sld>
 </file>
 
-<file path=ppt/slides/slide7.xml><?xml version="1.0" encoding="utf-8"?>
+<file path=ppt/slides/slide8.xml><?xml version="1.0" encoding="utf-8"?>
 <p:sld xmlns:a="http://schemas.openxmlformats.org/drawingml/2006/main" xmlns:r="http://schemas.openxmlformats.org/officeDocument/2006/relationships" xmlns:p="http://schemas.openxmlformats.org/presentationml/2006/main" showMasterSp="0">
   <p:cSld>
     <p:spTree>
@@ -23030,7 +23883,7 @@
                 <a:tabLst/>
                 <a:defRPr/>
               </a:pPr>
-              <a:t>7</a:t>
+              <a:t>8</a:t>
             </a:fld>
             <a:endParaRPr kumimoji="0" lang="en-US" sz="1400" b="1" i="1" u="none" strike="noStrike" kern="1200" cap="none" spc="0" normalizeH="0" baseline="0" noProof="0" dirty="0">
               <a:ln>
@@ -23083,299 +23936,6 @@
     <p:extLst>
       <p:ext uri="{BB962C8B-B14F-4D97-AF65-F5344CB8AC3E}">
         <p14:creationId xmlns:p14="http://schemas.microsoft.com/office/powerpoint/2010/main" val="1009585235"/>
-      </p:ext>
-    </p:extLst>
-  </p:cSld>
-  <p:clrMapOvr>
-    <a:masterClrMapping/>
-  </p:clrMapOvr>
-</p:sld>
-</file>
-
-<file path=ppt/slides/slide8.xml><?xml version="1.0" encoding="utf-8"?>
-<p:sld xmlns:a="http://schemas.openxmlformats.org/drawingml/2006/main" xmlns:r="http://schemas.openxmlformats.org/officeDocument/2006/relationships" xmlns:p="http://schemas.openxmlformats.org/presentationml/2006/main" showMasterSp="0">
-  <p:cSld>
-    <p:spTree>
-      <p:nvGrpSpPr>
-        <p:cNvPr id="1" name=""/>
-        <p:cNvGrpSpPr/>
-        <p:nvPr/>
-      </p:nvGrpSpPr>
-      <p:grpSpPr>
-        <a:xfrm>
-          <a:off x="0" y="0"/>
-          <a:ext cx="0" cy="0"/>
-          <a:chOff x="0" y="0"/>
-          <a:chExt cx="0" cy="0"/>
-        </a:xfrm>
-      </p:grpSpPr>
-      <p:pic>
-        <p:nvPicPr>
-          <p:cNvPr id="8" name="Picture Placeholder 7" descr="Arial image of table with medical instruments, medicine, a clipboard, and other medical equipment">
-            <a:extLst>
-              <a:ext uri="{FF2B5EF4-FFF2-40B4-BE49-F238E27FC236}">
-                <a16:creationId xmlns:a16="http://schemas.microsoft.com/office/drawing/2014/main" id="{0A756A3F-0F08-4577-8E72-1E643EFB097C}"/>
-              </a:ext>
-            </a:extLst>
-          </p:cNvPr>
-          <p:cNvPicPr>
-            <a:picLocks noGrp="1" noChangeAspect="1"/>
-          </p:cNvPicPr>
-          <p:nvPr>
-            <p:ph type="pic" sz="quarter" idx="4294967295"/>
-          </p:nvPr>
-        </p:nvPicPr>
-        <p:blipFill>
-          <a:blip r:embed="rId3" cstate="screen">
-            <a:extLst>
-              <a:ext uri="{28A0092B-C50C-407E-A947-70E740481C1C}">
-                <a14:useLocalDpi xmlns:a14="http://schemas.microsoft.com/office/drawing/2010/main"/>
-              </a:ext>
-            </a:extLst>
-          </a:blip>
-          <a:srcRect/>
-          <a:stretch>
-            <a:fillRect/>
-          </a:stretch>
-        </p:blipFill>
-        <p:spPr>
-          <a:xfrm>
-            <a:off x="294426" y="136525"/>
-            <a:ext cx="5259923" cy="6584168"/>
-          </a:xfrm>
-        </p:spPr>
-      </p:pic>
-      <p:sp>
-        <p:nvSpPr>
-          <p:cNvPr id="18" name="Rectangle 17">
-            <a:extLst>
-              <a:ext uri="{FF2B5EF4-FFF2-40B4-BE49-F238E27FC236}">
-                <a16:creationId xmlns:a16="http://schemas.microsoft.com/office/drawing/2014/main" id="{75F2B1C5-78F6-4A28-8883-7C500ADCB7D4}"/>
-              </a:ext>
-              <a:ext uri="{C183D7F6-B498-43B3-948B-1728B52AA6E4}">
-                <adec:decorative xmlns:adec="http://schemas.microsoft.com/office/drawing/2017/decorative" val="1"/>
-              </a:ext>
-            </a:extLst>
-          </p:cNvPr>
-          <p:cNvSpPr/>
-          <p:nvPr/>
-        </p:nvSpPr>
-        <p:spPr bwMode="invGray">
-          <a:xfrm rot="5400000">
-            <a:off x="5271215" y="419661"/>
-            <a:ext cx="6584950" cy="6018679"/>
-          </a:xfrm>
-          <a:prstGeom prst="rect">
-            <a:avLst/>
-          </a:prstGeom>
-          <a:solidFill>
-            <a:schemeClr val="tx1">
-              <a:alpha val="70000"/>
-            </a:schemeClr>
-          </a:solidFill>
-          <a:ln>
-            <a:noFill/>
-          </a:ln>
-        </p:spPr>
-        <p:style>
-          <a:lnRef idx="2">
-            <a:schemeClr val="accent1">
-              <a:shade val="50000"/>
-            </a:schemeClr>
-          </a:lnRef>
-          <a:fillRef idx="1">
-            <a:schemeClr val="accent1"/>
-          </a:fillRef>
-          <a:effectRef idx="0">
-            <a:schemeClr val="accent1"/>
-          </a:effectRef>
-          <a:fontRef idx="minor">
-            <a:schemeClr val="lt1"/>
-          </a:fontRef>
-        </p:style>
-        <p:txBody>
-          <a:bodyPr rtlCol="0" anchor="ctr"/>
-          <a:lstStyle/>
-          <a:p>
-            <a:pPr algn="ctr"/>
-            <a:endParaRPr lang="en-US" dirty="0"/>
-          </a:p>
-        </p:txBody>
-      </p:sp>
-      <p:sp>
-        <p:nvSpPr>
-          <p:cNvPr id="2" name="Title 1">
-            <a:extLst>
-              <a:ext uri="{FF2B5EF4-FFF2-40B4-BE49-F238E27FC236}">
-                <a16:creationId xmlns:a16="http://schemas.microsoft.com/office/drawing/2014/main" id="{B35ED38B-2505-420A-A14A-D41E71EDBA33}"/>
-              </a:ext>
-            </a:extLst>
-          </p:cNvPr>
-          <p:cNvSpPr>
-            <a:spLocks noGrp="1"/>
-          </p:cNvSpPr>
-          <p:nvPr>
-            <p:ph type="ctrTitle"/>
-          </p:nvPr>
-        </p:nvSpPr>
-        <p:spPr bwMode="black">
-          <a:xfrm>
-            <a:off x="6321400" y="256015"/>
-            <a:ext cx="3769734" cy="925671"/>
-          </a:xfrm>
-        </p:spPr>
-        <p:txBody>
-          <a:bodyPr/>
-          <a:lstStyle/>
-          <a:p>
-            <a:r>
-              <a:rPr lang="en-US" b="1" dirty="0"/>
-              <a:t>Conclusion</a:t>
-            </a:r>
-          </a:p>
-        </p:txBody>
-      </p:sp>
-      <p:sp>
-        <p:nvSpPr>
-          <p:cNvPr id="3" name="Subtitle 2">
-            <a:extLst>
-              <a:ext uri="{FF2B5EF4-FFF2-40B4-BE49-F238E27FC236}">
-                <a16:creationId xmlns:a16="http://schemas.microsoft.com/office/drawing/2014/main" id="{71F217F2-8C36-4584-BD5D-0B00606DF9A2}"/>
-              </a:ext>
-            </a:extLst>
-          </p:cNvPr>
-          <p:cNvSpPr>
-            <a:spLocks noGrp="1"/>
-          </p:cNvSpPr>
-          <p:nvPr>
-            <p:ph type="subTitle" idx="1"/>
-          </p:nvPr>
-        </p:nvSpPr>
-        <p:spPr bwMode="black">
-          <a:xfrm>
-            <a:off x="5795837" y="1301176"/>
-            <a:ext cx="5535706" cy="5154404"/>
-          </a:xfrm>
-        </p:spPr>
-        <p:txBody>
-          <a:bodyPr/>
-          <a:lstStyle/>
-          <a:p>
-            <a:pPr algn="l"/>
-            <a:r>
-              <a:rPr lang="en-US" b="1" dirty="0">
-                <a:solidFill>
-                  <a:schemeClr val="accent1">
-                    <a:lumMod val="60000"/>
-                    <a:lumOff val="40000"/>
-                  </a:schemeClr>
-                </a:solidFill>
-              </a:rPr>
-              <a:t>This study presents a deep Convolutional Neural Network (CNN) based approach for the automatic detection of Pneumonia. We constructed a CNN model from scratch to extract features from a given Chest X-Ray image and classify it to determine if a person is infected with Pneumonia.</a:t>
-            </a:r>
-          </a:p>
-          <a:p>
-            <a:pPr algn="l"/>
-            <a:br>
-              <a:rPr lang="en-US" dirty="0">
-                <a:solidFill>
-                  <a:schemeClr val="accent1">
-                    <a:lumMod val="60000"/>
-                    <a:lumOff val="40000"/>
-                  </a:schemeClr>
-                </a:solidFill>
-              </a:rPr>
-            </a:br>
-            <a:r>
-              <a:rPr lang="en-US" b="1" dirty="0">
-                <a:solidFill>
-                  <a:schemeClr val="accent1">
-                    <a:lumMod val="60000"/>
-                    <a:lumOff val="40000"/>
-                  </a:schemeClr>
-                </a:solidFill>
-              </a:rPr>
-              <a:t>We have demonstrated how to distinguish between Normal and Pneumonia Chest X-Rays with our model having an Accuracy of 89% and a Recall of 90%.</a:t>
-            </a:r>
-            <a:br>
-              <a:rPr lang="en-US" dirty="0">
-                <a:solidFill>
-                  <a:schemeClr val="accent1">
-                    <a:lumMod val="60000"/>
-                    <a:lumOff val="40000"/>
-                  </a:schemeClr>
-                </a:solidFill>
-              </a:rPr>
-            </a:br>
-            <a:endParaRPr lang="en-US" dirty="0">
-              <a:solidFill>
-                <a:schemeClr val="accent1">
-                  <a:lumMod val="60000"/>
-                  <a:lumOff val="40000"/>
-                </a:schemeClr>
-              </a:solidFill>
-            </a:endParaRPr>
-          </a:p>
-        </p:txBody>
-      </p:sp>
-      <p:sp>
-        <p:nvSpPr>
-          <p:cNvPr id="23" name="Slide Number Placeholder 22">
-            <a:extLst>
-              <a:ext uri="{FF2B5EF4-FFF2-40B4-BE49-F238E27FC236}">
-                <a16:creationId xmlns:a16="http://schemas.microsoft.com/office/drawing/2014/main" id="{4D5E33D6-D847-4F4C-BA8B-75CB853FAB76}"/>
-              </a:ext>
-            </a:extLst>
-          </p:cNvPr>
-          <p:cNvSpPr>
-            <a:spLocks noGrp="1"/>
-          </p:cNvSpPr>
-          <p:nvPr>
-            <p:ph type="sldNum" sz="quarter" idx="12"/>
-          </p:nvPr>
-        </p:nvSpPr>
-        <p:spPr>
-          <a:xfrm>
-            <a:off x="11416176" y="6455580"/>
-            <a:ext cx="962795" cy="264330"/>
-          </a:xfrm>
-          <a:ln>
-            <a:noFill/>
-          </a:ln>
-        </p:spPr>
-        <p:txBody>
-          <a:bodyPr/>
-          <a:lstStyle/>
-          <a:p>
-            <a:r>
-              <a:rPr lang="en-US" dirty="0">
-                <a:solidFill>
-                  <a:schemeClr val="bg1"/>
-                </a:solidFill>
-              </a:rPr>
-              <a:t>page </a:t>
-            </a:r>
-            <a:fld id="{19B51A1E-902D-48AF-9020-955120F399B6}" type="slidenum">
-              <a:rPr lang="en-US" smtClean="0">
-                <a:solidFill>
-                  <a:schemeClr val="bg1"/>
-                </a:solidFill>
-              </a:rPr>
-              <a:pPr/>
-              <a:t>8</a:t>
-            </a:fld>
-            <a:endParaRPr lang="en-US" dirty="0">
-              <a:solidFill>
-                <a:schemeClr val="bg1"/>
-              </a:solidFill>
-            </a:endParaRPr>
-          </a:p>
-        </p:txBody>
-      </p:sp>
-    </p:spTree>
-    <p:extLst>
-      <p:ext uri="{BB962C8B-B14F-4D97-AF65-F5344CB8AC3E}">
-        <p14:creationId xmlns:p14="http://schemas.microsoft.com/office/powerpoint/2010/main" val="2770099390"/>
       </p:ext>
     </p:extLst>
   </p:cSld>
@@ -23404,10 +23964,10 @@
       </p:grpSpPr>
       <p:pic>
         <p:nvPicPr>
-          <p:cNvPr id="8" name="Picture Placeholder 7" descr="Image containing medical tweezers of various sizes, some pills, and a hand holding a pen writing on a piece of paper attached to a clipboard">
-            <a:extLst>
-              <a:ext uri="{FF2B5EF4-FFF2-40B4-BE49-F238E27FC236}">
-                <a16:creationId xmlns:a16="http://schemas.microsoft.com/office/drawing/2014/main" id="{58E8F1D1-2E7D-42A1-89B1-02F0157F588D}"/>
+          <p:cNvPr id="8" name="Picture Placeholder 7" descr="Arial image of table with medical instruments, medicine, a clipboard, and other medical equipment">
+            <a:extLst>
+              <a:ext uri="{FF2B5EF4-FFF2-40B4-BE49-F238E27FC236}">
+                <a16:creationId xmlns:a16="http://schemas.microsoft.com/office/drawing/2014/main" id="{0A756A3F-0F08-4577-8E72-1E643EFB097C}"/>
               </a:ext>
             </a:extLst>
           </p:cNvPr>
@@ -23415,7 +23975,7 @@
             <a:picLocks noGrp="1" noChangeAspect="1"/>
           </p:cNvPicPr>
           <p:nvPr>
-            <p:ph type="pic" sz="quarter" idx="10"/>
+            <p:ph type="pic" sz="quarter" idx="4294967295"/>
           </p:nvPr>
         </p:nvPicPr>
         <p:blipFill>
@@ -23433,17 +23993,17 @@
         </p:blipFill>
         <p:spPr>
           <a:xfrm>
-            <a:off x="464754" y="135743"/>
-            <a:ext cx="11014483" cy="6584950"/>
+            <a:off x="294426" y="136525"/>
+            <a:ext cx="5259923" cy="6584168"/>
           </a:xfrm>
         </p:spPr>
       </p:pic>
       <p:sp>
         <p:nvSpPr>
-          <p:cNvPr id="12" name="Rectangle 11">
-            <a:extLst>
-              <a:ext uri="{FF2B5EF4-FFF2-40B4-BE49-F238E27FC236}">
-                <a16:creationId xmlns:a16="http://schemas.microsoft.com/office/drawing/2014/main" id="{1D3F6556-8AF2-4DC2-86FE-E38011E946E6}"/>
+          <p:cNvPr id="18" name="Rectangle 17">
+            <a:extLst>
+              <a:ext uri="{FF2B5EF4-FFF2-40B4-BE49-F238E27FC236}">
+                <a16:creationId xmlns:a16="http://schemas.microsoft.com/office/drawing/2014/main" id="{75F2B1C5-78F6-4A28-8883-7C500ADCB7D4}"/>
               </a:ext>
               <a:ext uri="{C183D7F6-B498-43B3-948B-1728B52AA6E4}">
                 <adec:decorative xmlns:adec="http://schemas.microsoft.com/office/drawing/2017/decorative" val="1"/>
@@ -23455,8 +24015,8 @@
         </p:nvSpPr>
         <p:spPr bwMode="invGray">
           <a:xfrm rot="5400000">
-            <a:off x="5548442" y="438205"/>
-            <a:ext cx="6584950" cy="6064435"/>
+            <a:off x="5271215" y="419661"/>
+            <a:ext cx="6584950" cy="6018679"/>
           </a:xfrm>
           <a:prstGeom prst="rect">
             <a:avLst/>
@@ -23497,10 +24057,10 @@
       </p:sp>
       <p:sp>
         <p:nvSpPr>
-          <p:cNvPr id="3" name="Title 2">
-            <a:extLst>
-              <a:ext uri="{FF2B5EF4-FFF2-40B4-BE49-F238E27FC236}">
-                <a16:creationId xmlns:a16="http://schemas.microsoft.com/office/drawing/2014/main" id="{697DC055-29AA-4AE9-8621-A0765113CDFB}"/>
+          <p:cNvPr id="2" name="Title 1">
+            <a:extLst>
+              <a:ext uri="{FF2B5EF4-FFF2-40B4-BE49-F238E27FC236}">
+                <a16:creationId xmlns:a16="http://schemas.microsoft.com/office/drawing/2014/main" id="{B35ED38B-2505-420A-A14A-D41E71EDBA33}"/>
               </a:ext>
             </a:extLst>
           </p:cNvPr>
@@ -23513,8 +24073,8 @@
         </p:nvSpPr>
         <p:spPr bwMode="black">
           <a:xfrm>
-            <a:off x="5808699" y="400073"/>
-            <a:ext cx="5085650" cy="691666"/>
+            <a:off x="6321400" y="256015"/>
+            <a:ext cx="3769734" cy="925671"/>
           </a:xfrm>
         </p:spPr>
         <p:txBody>
@@ -23523,17 +24083,17 @@
           <a:p>
             <a:r>
               <a:rPr lang="en-US" b="1" dirty="0"/>
-              <a:t>Recommendations:</a:t>
-            </a:r>
-          </a:p>
-        </p:txBody>
-      </p:sp>
-      <p:sp>
-        <p:nvSpPr>
-          <p:cNvPr id="4" name="Subtitle 3">
-            <a:extLst>
-              <a:ext uri="{FF2B5EF4-FFF2-40B4-BE49-F238E27FC236}">
-                <a16:creationId xmlns:a16="http://schemas.microsoft.com/office/drawing/2014/main" id="{4CAFB058-F34E-4FAC-AA90-D1CB170C9984}"/>
+              <a:t>Conclusion</a:t>
+            </a:r>
+          </a:p>
+        </p:txBody>
+      </p:sp>
+      <p:sp>
+        <p:nvSpPr>
+          <p:cNvPr id="3" name="Subtitle 2">
+            <a:extLst>
+              <a:ext uri="{FF2B5EF4-FFF2-40B4-BE49-F238E27FC236}">
+                <a16:creationId xmlns:a16="http://schemas.microsoft.com/office/drawing/2014/main" id="{71F217F2-8C36-4584-BD5D-0B00606DF9A2}"/>
               </a:ext>
             </a:extLst>
           </p:cNvPr>
@@ -23546,8 +24106,8 @@
         </p:nvSpPr>
         <p:spPr bwMode="black">
           <a:xfrm>
-            <a:off x="6194484" y="1218512"/>
-            <a:ext cx="5383228" cy="4419412"/>
+            <a:off x="5795837" y="1301176"/>
+            <a:ext cx="5535706" cy="5154404"/>
           </a:xfrm>
         </p:spPr>
         <p:txBody>
@@ -23558,59 +24118,54 @@
             <a:r>
               <a:rPr lang="en-US" b="1" dirty="0">
                 <a:solidFill>
-                  <a:srgbClr val="FFC000"/>
+                  <a:schemeClr val="accent1">
+                    <a:lumMod val="60000"/>
+                    <a:lumOff val="40000"/>
+                  </a:schemeClr>
                 </a:solidFill>
               </a:rPr>
-              <a:t>Incorporate our model to see how it works in hospitals so that it can assist health professionals diagnose patients with Pneumonia. </a:t>
-            </a:r>
-          </a:p>
-          <a:p>
-            <a:pPr algn="l"/>
-            <a:r>
-              <a:rPr lang="en-US" b="1" dirty="0">
-                <a:solidFill>
-                  <a:srgbClr val="FFC000"/>
-                </a:solidFill>
-              </a:rPr>
-              <a:t>Of course these reports must be validated. This is not the ultimate test. This needs to be certified by health professionals.</a:t>
+              <a:t>This study presents a deep Convolutional Neural Network (CNN) based approach for the automatic detection of Pneumonia. We constructed a CNN model from scratch to extract features from a given Chest X-Ray image and classify it to determine if a person is infected with Pneumonia.</a:t>
             </a:r>
           </a:p>
           <a:p>
             <a:pPr algn="l"/>
             <a:br>
-              <a:rPr lang="en-US" b="1" dirty="0">
-                <a:solidFill>
-                  <a:srgbClr val="FFC000"/>
+              <a:rPr lang="en-US" dirty="0">
+                <a:solidFill>
+                  <a:schemeClr val="accent1">
+                    <a:lumMod val="60000"/>
+                    <a:lumOff val="40000"/>
+                  </a:schemeClr>
                 </a:solidFill>
               </a:rPr>
             </a:br>
             <a:r>
               <a:rPr lang="en-US" b="1" dirty="0">
                 <a:solidFill>
-                  <a:srgbClr val="FFC000"/>
+                  <a:schemeClr val="accent1">
+                    <a:lumMod val="60000"/>
+                    <a:lumOff val="40000"/>
+                  </a:schemeClr>
                 </a:solidFill>
               </a:rPr>
-              <a:t>This model should be run under the supervision of a radiologist to enhance accuracy/recall to improve treatment outcomes which will increase hospitals ratings and </a:t>
-            </a:r>
-            <a:r>
-              <a:rPr lang="en-US" b="1" dirty="0" err="1">
-                <a:solidFill>
-                  <a:srgbClr val="FFC000"/>
+              <a:t>We have demonstrated how to distinguish between Normal and Pneumonia Chest X-Rays with our model having an Accuracy of 89% and a Recall of 90%.</a:t>
+            </a:r>
+            <a:br>
+              <a:rPr lang="en-US" dirty="0">
+                <a:solidFill>
+                  <a:schemeClr val="accent1">
+                    <a:lumMod val="60000"/>
+                    <a:lumOff val="40000"/>
+                  </a:schemeClr>
                 </a:solidFill>
               </a:rPr>
-              <a:t>fundings</a:t>
-            </a:r>
-            <a:r>
-              <a:rPr lang="en-US" b="1" dirty="0">
-                <a:solidFill>
-                  <a:srgbClr val="FFC000"/>
-                </a:solidFill>
-              </a:rPr>
-              <a:t>.</a:t>
-            </a:r>
+            </a:br>
             <a:endParaRPr lang="en-US" dirty="0">
               <a:solidFill>
-                <a:srgbClr val="FFC000"/>
+                <a:schemeClr val="accent1">
+                  <a:lumMod val="60000"/>
+                  <a:lumOff val="40000"/>
+                </a:schemeClr>
               </a:solidFill>
             </a:endParaRPr>
           </a:p>
@@ -23618,10 +24173,10 @@
       </p:sp>
       <p:sp>
         <p:nvSpPr>
-          <p:cNvPr id="5" name="Slide Number Placeholder 4">
-            <a:extLst>
-              <a:ext uri="{FF2B5EF4-FFF2-40B4-BE49-F238E27FC236}">
-                <a16:creationId xmlns:a16="http://schemas.microsoft.com/office/drawing/2014/main" id="{631703FA-65E2-4E60-B9CE-387169A2F4AE}"/>
+          <p:cNvPr id="23" name="Slide Number Placeholder 22">
+            <a:extLst>
+              <a:ext uri="{FF2B5EF4-FFF2-40B4-BE49-F238E27FC236}">
+                <a16:creationId xmlns:a16="http://schemas.microsoft.com/office/drawing/2014/main" id="{4D5E33D6-D847-4F4C-BA8B-75CB853FAB76}"/>
               </a:ext>
             </a:extLst>
           </p:cNvPr>
@@ -23634,7 +24189,7 @@
         </p:nvSpPr>
         <p:spPr>
           <a:xfrm>
-            <a:off x="11245848" y="6456363"/>
+            <a:off x="11416176" y="6455580"/>
             <a:ext cx="962795" cy="264330"/>
           </a:xfrm>
           <a:ln>
@@ -23654,7 +24209,7 @@
               <a:t>page </a:t>
             </a:r>
             <a:fld id="{19B51A1E-902D-48AF-9020-955120F399B6}" type="slidenum">
-              <a:rPr lang="en-US" b="1" i="1" smtClean="0">
+              <a:rPr lang="en-US" smtClean="0">
                 <a:solidFill>
                   <a:schemeClr val="bg1"/>
                 </a:solidFill>
@@ -23662,7 +24217,7 @@
               <a:pPr/>
               <a:t>9</a:t>
             </a:fld>
-            <a:endParaRPr lang="en-US" b="1" i="1" dirty="0">
+            <a:endParaRPr lang="en-US" dirty="0">
               <a:solidFill>
                 <a:schemeClr val="bg1"/>
               </a:solidFill>
@@ -23673,7 +24228,7 @@
     </p:spTree>
     <p:extLst>
       <p:ext uri="{BB962C8B-B14F-4D97-AF65-F5344CB8AC3E}">
-        <p14:creationId xmlns:p14="http://schemas.microsoft.com/office/powerpoint/2010/main" val="833142177"/>
+        <p14:creationId xmlns:p14="http://schemas.microsoft.com/office/powerpoint/2010/main" val="2770099390"/>
       </p:ext>
     </p:extLst>
   </p:cSld>
@@ -24579,6 +25134,14 @@
 </file>
 
 <file path=customXml/item2.xml><?xml version="1.0" encoding="utf-8"?>
+<p:properties xmlns:p="http://schemas.microsoft.com/office/2006/metadata/properties" xmlns:xsi="http://www.w3.org/2001/XMLSchema-instance" xmlns:pc="http://schemas.microsoft.com/office/infopath/2007/PartnerControls">
+  <documentManagement>
+    <MediaServiceKeyPoints xmlns="71af3243-3dd4-4a8d-8c0d-dd76da1f02a5" xsi:nil="true"/>
+  </documentManagement>
+</p:properties>
+</file>
+
+<file path=customXml/item3.xml><?xml version="1.0" encoding="utf-8"?>
 <ct:contentTypeSchema xmlns:ct="http://schemas.microsoft.com/office/2006/metadata/contentType" xmlns:ma="http://schemas.microsoft.com/office/2006/metadata/properties/metaAttributes" ct:_="" ma:_="" ma:contentTypeName="Document" ma:contentTypeID="0x01010079F111ED35F8CC479449609E8A0923A6" ma:contentTypeVersion="11" ma:contentTypeDescription="Create a new document." ma:contentTypeScope="" ma:versionID="9677210f24a1be23c92c90fd886aa0aa">
   <xsd:schema xmlns:xsd="http://www.w3.org/2001/XMLSchema" xmlns:xs="http://www.w3.org/2001/XMLSchema" xmlns:p="http://schemas.microsoft.com/office/2006/metadata/properties" xmlns:ns2="71af3243-3dd4-4a8d-8c0d-dd76da1f02a5" xmlns:ns3="16c05727-aa75-4e4a-9b5f-8a80a1165891" targetNamespace="http://schemas.microsoft.com/office/2006/metadata/properties" ma:root="true" ma:fieldsID="60e05723c5c1908df1a1a4ebf11d344e" ns2:_="" ns3:_="">
     <xsd:import namespace="71af3243-3dd4-4a8d-8c0d-dd76da1f02a5"/>
@@ -24789,14 +25352,6 @@
 </ct:contentTypeSchema>
 </file>
 
-<file path=customXml/item3.xml><?xml version="1.0" encoding="utf-8"?>
-<p:properties xmlns:p="http://schemas.microsoft.com/office/2006/metadata/properties" xmlns:xsi="http://www.w3.org/2001/XMLSchema-instance" xmlns:pc="http://schemas.microsoft.com/office/infopath/2007/PartnerControls">
-  <documentManagement>
-    <MediaServiceKeyPoints xmlns="71af3243-3dd4-4a8d-8c0d-dd76da1f02a5" xsi:nil="true"/>
-  </documentManagement>
-</p:properties>
-</file>
-
 <file path=customXml/itemProps1.xml><?xml version="1.0" encoding="utf-8"?>
 <ds:datastoreItem xmlns:ds="http://schemas.openxmlformats.org/officeDocument/2006/customXml" ds:itemID="{5FFFEA1C-4D28-422A-816B-51B2F61D85DA}">
   <ds:schemaRefs>
@@ -24806,6 +25361,23 @@
 </file>
 
 <file path=customXml/itemProps2.xml><?xml version="1.0" encoding="utf-8"?>
+<ds:datastoreItem xmlns:ds="http://schemas.openxmlformats.org/officeDocument/2006/customXml" ds:itemID="{270A2AAC-D70B-4233-9389-268D6896774D}">
+  <ds:schemaRefs>
+    <ds:schemaRef ds:uri="http://purl.org/dc/elements/1.1/"/>
+    <ds:schemaRef ds:uri="http://schemas.microsoft.com/office/2006/metadata/properties"/>
+    <ds:schemaRef ds:uri="http://schemas.microsoft.com/office/2006/documentManagement/types"/>
+    <ds:schemaRef ds:uri="http://purl.org/dc/terms/"/>
+    <ds:schemaRef ds:uri="http://schemas.openxmlformats.org/package/2006/metadata/core-properties"/>
+    <ds:schemaRef ds:uri="16c05727-aa75-4e4a-9b5f-8a80a1165891"/>
+    <ds:schemaRef ds:uri="http://purl.org/dc/dcmitype/"/>
+    <ds:schemaRef ds:uri="http://schemas.microsoft.com/office/infopath/2007/PartnerControls"/>
+    <ds:schemaRef ds:uri="71af3243-3dd4-4a8d-8c0d-dd76da1f02a5"/>
+    <ds:schemaRef ds:uri="http://www.w3.org/XML/1998/namespace"/>
+  </ds:schemaRefs>
+</ds:datastoreItem>
+</file>
+
+<file path=customXml/itemProps3.xml><?xml version="1.0" encoding="utf-8"?>
 <ds:datastoreItem xmlns:ds="http://schemas.openxmlformats.org/officeDocument/2006/customXml" ds:itemID="{172D1CBC-A6D2-4C27-A0DD-244AE04E36B7}">
   <ds:schemaRefs>
     <ds:schemaRef ds:uri="http://schemas.microsoft.com/office/2006/metadata/contentType"/>
@@ -24822,21 +25394,4 @@
     <ds:schemaRef ds:uri="http://schemas.microsoft.com/internal/obd"/>
   </ds:schemaRefs>
 </ds:datastoreItem>
-</file>
-
-<file path=customXml/itemProps3.xml><?xml version="1.0" encoding="utf-8"?>
-<ds:datastoreItem xmlns:ds="http://schemas.openxmlformats.org/officeDocument/2006/customXml" ds:itemID="{270A2AAC-D70B-4233-9389-268D6896774D}">
-  <ds:schemaRefs>
-    <ds:schemaRef ds:uri="http://purl.org/dc/elements/1.1/"/>
-    <ds:schemaRef ds:uri="http://schemas.microsoft.com/office/2006/metadata/properties"/>
-    <ds:schemaRef ds:uri="http://schemas.microsoft.com/office/2006/documentManagement/types"/>
-    <ds:schemaRef ds:uri="http://purl.org/dc/terms/"/>
-    <ds:schemaRef ds:uri="http://schemas.openxmlformats.org/package/2006/metadata/core-properties"/>
-    <ds:schemaRef ds:uri="16c05727-aa75-4e4a-9b5f-8a80a1165891"/>
-    <ds:schemaRef ds:uri="http://purl.org/dc/dcmitype/"/>
-    <ds:schemaRef ds:uri="http://schemas.microsoft.com/office/infopath/2007/PartnerControls"/>
-    <ds:schemaRef ds:uri="71af3243-3dd4-4a8d-8c0d-dd76da1f02a5"/>
-    <ds:schemaRef ds:uri="http://www.w3.org/XML/1998/namespace"/>
-  </ds:schemaRefs>
-</ds:datastoreItem>
 </file>
</xml_diff>